<commit_message>
Revise Fig 1A: day-scaled timeline with 2-day divert arms
Match Fig. 1 panel A: remove 2d FA; fix dots 1.5–7.5 d; five X arms
from 1.5–5.5 d (2 d each); CA/Ecto/Meso/Endo legend; hPSC day-0 bar.

Co-authored-by: LiAng Yao <LiAngYao-l@users.noreply.github.com>
</commit_message>
<xml_diff>
--- a/figures/fig1a/fig1a_pgc_induction.pptx
+++ b/figures/fig1a/fig1a_pgc_induction.pptx
@@ -7,7 +7,7 @@
   <p:sldIdLst>
     <p:sldId id="256" r:id="rId7"/>
   </p:sldIdLst>
-  <p:sldSz cx="6766560" cy="3749039" type="screen4x3"/>
+  <p:sldSz cx="6949440" cy="3383280" type="screen4x3"/>
   <p:notesSz cx="6858000" cy="9144000"/>
   <p:defaultTextStyle>
     <a:defPPr>
@@ -3096,8 +3096,8 @@
         </p:nvSpPr>
         <p:spPr>
           <a:xfrm>
-            <a:off x="137160" y="91440"/>
-            <a:ext cx="292608" cy="274320"/>
+            <a:off x="91440" y="36576"/>
+            <a:ext cx="237744" cy="219456"/>
           </a:xfrm>
           <a:prstGeom prst="rect">
             <a:avLst/>
@@ -3112,7 +3112,7 @@
           <a:p>
             <a:pPr algn="l"/>
             <a:r>
-              <a:rPr sz="1400" b="1">
+              <a:rPr sz="1300" b="1">
                 <a:solidFill>
                   <a:srgbClr val="000000"/>
                 </a:solidFill>
@@ -3131,8 +3131,8 @@
         </p:nvSpPr>
         <p:spPr>
           <a:xfrm>
-            <a:off x="384048" y="256032"/>
-            <a:ext cx="1828800" cy="256032"/>
+            <a:off x="310896" y="45720"/>
+            <a:ext cx="6400800" cy="201168"/>
           </a:xfrm>
           <a:prstGeom prst="rect">
             <a:avLst/>
@@ -3147,67 +3147,32 @@
           <a:p>
             <a:pPr algn="l"/>
             <a:r>
-              <a:rPr sz="1200" b="1">
+              <a:rPr sz="1000" b="1">
                 <a:solidFill>
                   <a:srgbClr val="000000"/>
                 </a:solidFill>
                 <a:latin typeface="Arial"/>
               </a:rPr>
-              <a:t>PGC induction:</a:t>
-            </a:r>
-          </a:p>
-        </p:txBody>
-      </p:sp>
-      <p:sp>
-        <p:nvSpPr>
-          <p:cNvPr id="4" name="TextBox 3"/>
-          <p:cNvSpPr txBox="1"/>
-          <p:nvPr/>
-        </p:nvSpPr>
-        <p:spPr>
-          <a:xfrm>
-            <a:off x="960120" y="18288"/>
-            <a:ext cx="640080" cy="182880"/>
-          </a:xfrm>
-          <a:prstGeom prst="rect">
-            <a:avLst/>
-          </a:prstGeom>
-          <a:noFill/>
-        </p:spPr>
-        <p:txBody>
-          <a:bodyPr wrap="square">
-            <a:spAutoFit/>
-          </a:bodyPr>
-          <a:lstStyle/>
-          <a:p>
-            <a:pPr algn="ctr"/>
-            <a:r>
-              <a:rPr sz="900" b="0">
-                <a:solidFill>
-                  <a:srgbClr val="000000"/>
-                </a:solidFill>
-                <a:latin typeface="Arial"/>
-              </a:rPr>
-              <a:t>2d FA</a:t>
+              <a:t>Protocols for hPGCLC specification, maintenance and DE convergence.</a:t>
             </a:r>
           </a:p>
         </p:txBody>
       </p:sp>
       <p:cxnSp>
         <p:nvCxnSpPr>
-          <p:cNvPr id="5" name="Connector 4"/>
+          <p:cNvPr id="4" name="Connector 3"/>
           <p:cNvCxnSpPr/>
           <p:nvPr/>
         </p:nvCxnSpPr>
         <p:spPr>
           <a:xfrm>
-            <a:off x="1280160" y="182880"/>
-            <a:ext cx="0" cy="178765"/>
+            <a:off x="777240" y="685800"/>
+            <a:ext cx="0" cy="365760"/>
           </a:xfrm>
           <a:prstGeom prst="line">
             <a:avLst/>
           </a:prstGeom>
-          <a:ln w="14604">
+          <a:ln w="18415">
             <a:solidFill>
               <a:srgbClr val="000000"/>
             </a:solidFill>
@@ -3230,62 +3195,54 @@
       </p:cxnSp>
       <p:sp>
         <p:nvSpPr>
-          <p:cNvPr id="6" name="Isosceles Triangle 5"/>
-          <p:cNvSpPr/>
+          <p:cNvPr id="5" name="TextBox 4"/>
+          <p:cNvSpPr txBox="1"/>
           <p:nvPr/>
         </p:nvSpPr>
         <p:spPr>
-          <a:xfrm rot="10800000">
-            <a:off x="1244955" y="320040"/>
-            <a:ext cx="70408" cy="64008"/>
-          </a:xfrm>
-          <a:prstGeom prst="triangle">
-            <a:avLst/>
-          </a:prstGeom>
-          <a:solidFill>
-            <a:srgbClr val="000000"/>
-          </a:solidFill>
-          <a:ln>
-            <a:noFill/>
-          </a:ln>
-        </p:spPr>
-        <p:style>
-          <a:lnRef idx="1">
-            <a:schemeClr val="accent1"/>
-          </a:lnRef>
-          <a:fillRef idx="3">
-            <a:schemeClr val="accent1"/>
-          </a:fillRef>
-          <a:effectRef idx="2">
-            <a:schemeClr val="accent1"/>
-          </a:effectRef>
-          <a:fontRef idx="minor">
-            <a:schemeClr val="lt1"/>
-          </a:fontRef>
-        </p:style>
-        <p:txBody>
-          <a:bodyPr rtlCol="0" anchor="ctr"/>
+          <a:xfrm>
+            <a:off x="320040" y="484632"/>
+            <a:ext cx="914400" cy="182880"/>
+          </a:xfrm>
+          <a:prstGeom prst="rect">
+            <a:avLst/>
+          </a:prstGeom>
+          <a:noFill/>
+        </p:spPr>
+        <p:txBody>
+          <a:bodyPr wrap="square">
+            <a:spAutoFit/>
+          </a:bodyPr>
           <a:lstStyle/>
           <a:p>
             <a:pPr algn="ctr"/>
+            <a:r>
+              <a:rPr sz="900" b="1">
+                <a:solidFill>
+                  <a:srgbClr val="000000"/>
+                </a:solidFill>
+                <a:latin typeface="Arial"/>
+              </a:rPr>
+              <a:t>hPSCs</a:t>
+            </a:r>
           </a:p>
         </p:txBody>
       </p:sp>
       <p:cxnSp>
         <p:nvCxnSpPr>
-          <p:cNvPr id="7" name="Connector 6"/>
+          <p:cNvPr id="6" name="Connector 5"/>
           <p:cNvCxnSpPr/>
           <p:nvPr/>
         </p:nvCxnSpPr>
         <p:spPr>
           <a:xfrm>
-            <a:off x="640080" y="1234440"/>
-            <a:ext cx="5623560" cy="0"/>
+            <a:off x="777240" y="868680"/>
+            <a:ext cx="5852160" cy="0"/>
           </a:xfrm>
           <a:prstGeom prst="line">
             <a:avLst/>
           </a:prstGeom>
-          <a:ln w="19050">
+          <a:ln w="18415">
             <a:solidFill>
               <a:srgbClr val="000000"/>
             </a:solidFill>
@@ -3306,6 +3263,41 @@
           </a:fontRef>
         </p:style>
       </p:cxnSp>
+      <p:sp>
+        <p:nvSpPr>
+          <p:cNvPr id="7" name="TextBox 6"/>
+          <p:cNvSpPr txBox="1"/>
+          <p:nvPr/>
+        </p:nvSpPr>
+        <p:spPr>
+          <a:xfrm>
+            <a:off x="777240" y="576071"/>
+            <a:ext cx="1560576" cy="182880"/>
+          </a:xfrm>
+          <a:prstGeom prst="rect">
+            <a:avLst/>
+          </a:prstGeom>
+          <a:noFill/>
+        </p:spPr>
+        <p:txBody>
+          <a:bodyPr wrap="square">
+            <a:spAutoFit/>
+          </a:bodyPr>
+          <a:lstStyle/>
+          <a:p>
+            <a:pPr algn="ctr"/>
+            <a:r>
+              <a:rPr sz="900" b="1">
+                <a:solidFill>
+                  <a:srgbClr val="000000"/>
+                </a:solidFill>
+                <a:latin typeface="Arial"/>
+              </a:rPr>
+              <a:t>CA</a:t>
+            </a:r>
+          </a:p>
+        </p:txBody>
+      </p:sp>
       <p:cxnSp>
         <p:nvCxnSpPr>
           <p:cNvPr id="8" name="Connector 7"/>
@@ -3314,13 +3306,13 @@
         </p:nvCxnSpPr>
         <p:spPr>
           <a:xfrm>
-            <a:off x="640080" y="1161288"/>
-            <a:ext cx="0" cy="146304"/>
+            <a:off x="777240" y="777240"/>
+            <a:ext cx="1560576" cy="0"/>
           </a:xfrm>
           <a:prstGeom prst="line">
             <a:avLst/>
           </a:prstGeom>
-          <a:ln w="14604">
+          <a:ln w="13970">
             <a:solidFill>
               <a:srgbClr val="000000"/>
             </a:solidFill>
@@ -3349,13 +3341,13 @@
         </p:nvCxnSpPr>
         <p:spPr>
           <a:xfrm>
-            <a:off x="1417320" y="1161288"/>
-            <a:ext cx="0" cy="146304"/>
+            <a:off x="777240" y="777240"/>
+            <a:ext cx="0" cy="43891"/>
           </a:xfrm>
           <a:prstGeom prst="line">
             <a:avLst/>
           </a:prstGeom>
-          <a:ln w="14604">
+          <a:ln w="13970">
             <a:solidFill>
               <a:srgbClr val="000000"/>
             </a:solidFill>
@@ -3384,16 +3376,633 @@
         </p:nvCxnSpPr>
         <p:spPr>
           <a:xfrm>
-            <a:off x="640080" y="1362456"/>
-            <a:ext cx="0" cy="91440"/>
+            <a:off x="2337816" y="777240"/>
+            <a:ext cx="0" cy="43891"/>
           </a:xfrm>
           <a:prstGeom prst="line">
             <a:avLst/>
           </a:prstGeom>
-          <a:ln w="14604">
+          <a:ln w="13970">
             <a:solidFill>
               <a:srgbClr val="000000"/>
             </a:solidFill>
+          </a:ln>
+        </p:spPr>
+        <p:style>
+          <a:lnRef idx="2">
+            <a:schemeClr val="accent1"/>
+          </a:lnRef>
+          <a:fillRef idx="0">
+            <a:schemeClr val="accent1"/>
+          </a:fillRef>
+          <a:effectRef idx="1">
+            <a:schemeClr val="accent1"/>
+          </a:effectRef>
+          <a:fontRef idx="minor">
+            <a:schemeClr val="tx1"/>
+          </a:fontRef>
+        </p:style>
+      </p:cxnSp>
+      <p:sp>
+        <p:nvSpPr>
+          <p:cNvPr id="11" name="TextBox 10"/>
+          <p:cNvSpPr txBox="1"/>
+          <p:nvPr/>
+        </p:nvSpPr>
+        <p:spPr>
+          <a:xfrm>
+            <a:off x="2410968" y="576071"/>
+            <a:ext cx="4218432" cy="182880"/>
+          </a:xfrm>
+          <a:prstGeom prst="rect">
+            <a:avLst/>
+          </a:prstGeom>
+          <a:noFill/>
+        </p:spPr>
+        <p:txBody>
+          <a:bodyPr wrap="square">
+            <a:spAutoFit/>
+          </a:bodyPr>
+          <a:lstStyle/>
+          <a:p>
+            <a:pPr algn="ctr"/>
+            <a:r>
+              <a:rPr sz="1000" b="1">
+                <a:solidFill>
+                  <a:srgbClr val="000000"/>
+                </a:solidFill>
+                <a:latin typeface="Arial"/>
+              </a:rPr>
+              <a:t>BMP + SCF + EGF</a:t>
+            </a:r>
+          </a:p>
+        </p:txBody>
+      </p:sp>
+      <p:sp>
+        <p:nvSpPr>
+          <p:cNvPr id="12" name="Oval 11"/>
+          <p:cNvSpPr/>
+          <p:nvPr/>
+        </p:nvSpPr>
+        <p:spPr>
+          <a:xfrm>
+            <a:off x="1909267" y="830275"/>
+            <a:ext cx="76809" cy="76809"/>
+          </a:xfrm>
+          <a:prstGeom prst="ellipse">
+            <a:avLst/>
+          </a:prstGeom>
+          <a:solidFill>
+            <a:srgbClr val="000000"/>
+          </a:solidFill>
+          <a:ln>
+            <a:noFill/>
+          </a:ln>
+        </p:spPr>
+        <p:style>
+          <a:lnRef idx="1">
+            <a:schemeClr val="accent1"/>
+          </a:lnRef>
+          <a:fillRef idx="3">
+            <a:schemeClr val="accent1"/>
+          </a:fillRef>
+          <a:effectRef idx="2">
+            <a:schemeClr val="accent1"/>
+          </a:effectRef>
+          <a:fontRef idx="minor">
+            <a:schemeClr val="lt1"/>
+          </a:fontRef>
+        </p:style>
+        <p:txBody>
+          <a:bodyPr rtlCol="0" anchor="ctr"/>
+          <a:lstStyle/>
+          <a:p>
+            <a:pPr algn="ctr"/>
+          </a:p>
+        </p:txBody>
+      </p:sp>
+      <p:sp>
+        <p:nvSpPr>
+          <p:cNvPr id="13" name="TextBox 12"/>
+          <p:cNvSpPr txBox="1"/>
+          <p:nvPr/>
+        </p:nvSpPr>
+        <p:spPr>
+          <a:xfrm>
+            <a:off x="1673352" y="941832"/>
+            <a:ext cx="548640" cy="146304"/>
+          </a:xfrm>
+          <a:prstGeom prst="rect">
+            <a:avLst/>
+          </a:prstGeom>
+          <a:noFill/>
+        </p:spPr>
+        <p:txBody>
+          <a:bodyPr wrap="square">
+            <a:spAutoFit/>
+          </a:bodyPr>
+          <a:lstStyle/>
+          <a:p>
+            <a:pPr algn="ctr"/>
+            <a:r>
+              <a:rPr sz="700" b="0">
+                <a:solidFill>
+                  <a:srgbClr val="000000"/>
+                </a:solidFill>
+                <a:latin typeface="Arial"/>
+              </a:rPr>
+              <a:t>1.5d</a:t>
+            </a:r>
+          </a:p>
+        </p:txBody>
+      </p:sp>
+      <p:sp>
+        <p:nvSpPr>
+          <p:cNvPr id="14" name="Oval 13"/>
+          <p:cNvSpPr/>
+          <p:nvPr/>
+        </p:nvSpPr>
+        <p:spPr>
+          <a:xfrm>
+            <a:off x="2689555" y="830275"/>
+            <a:ext cx="76809" cy="76809"/>
+          </a:xfrm>
+          <a:prstGeom prst="ellipse">
+            <a:avLst/>
+          </a:prstGeom>
+          <a:solidFill>
+            <a:srgbClr val="000000"/>
+          </a:solidFill>
+          <a:ln>
+            <a:noFill/>
+          </a:ln>
+        </p:spPr>
+        <p:style>
+          <a:lnRef idx="1">
+            <a:schemeClr val="accent1"/>
+          </a:lnRef>
+          <a:fillRef idx="3">
+            <a:schemeClr val="accent1"/>
+          </a:fillRef>
+          <a:effectRef idx="2">
+            <a:schemeClr val="accent1"/>
+          </a:effectRef>
+          <a:fontRef idx="minor">
+            <a:schemeClr val="lt1"/>
+          </a:fontRef>
+        </p:style>
+        <p:txBody>
+          <a:bodyPr rtlCol="0" anchor="ctr"/>
+          <a:lstStyle/>
+          <a:p>
+            <a:pPr algn="ctr"/>
+          </a:p>
+        </p:txBody>
+      </p:sp>
+      <p:sp>
+        <p:nvSpPr>
+          <p:cNvPr id="15" name="TextBox 14"/>
+          <p:cNvSpPr txBox="1"/>
+          <p:nvPr/>
+        </p:nvSpPr>
+        <p:spPr>
+          <a:xfrm>
+            <a:off x="2453640" y="941832"/>
+            <a:ext cx="548640" cy="146304"/>
+          </a:xfrm>
+          <a:prstGeom prst="rect">
+            <a:avLst/>
+          </a:prstGeom>
+          <a:noFill/>
+        </p:spPr>
+        <p:txBody>
+          <a:bodyPr wrap="square">
+            <a:spAutoFit/>
+          </a:bodyPr>
+          <a:lstStyle/>
+          <a:p>
+            <a:pPr algn="ctr"/>
+            <a:r>
+              <a:rPr sz="700" b="0">
+                <a:solidFill>
+                  <a:srgbClr val="000000"/>
+                </a:solidFill>
+                <a:latin typeface="Arial"/>
+              </a:rPr>
+              <a:t>2.5d</a:t>
+            </a:r>
+          </a:p>
+        </p:txBody>
+      </p:sp>
+      <p:sp>
+        <p:nvSpPr>
+          <p:cNvPr id="16" name="Oval 15"/>
+          <p:cNvSpPr/>
+          <p:nvPr/>
+        </p:nvSpPr>
+        <p:spPr>
+          <a:xfrm>
+            <a:off x="3469843" y="830275"/>
+            <a:ext cx="76809" cy="76809"/>
+          </a:xfrm>
+          <a:prstGeom prst="ellipse">
+            <a:avLst/>
+          </a:prstGeom>
+          <a:solidFill>
+            <a:srgbClr val="000000"/>
+          </a:solidFill>
+          <a:ln>
+            <a:noFill/>
+          </a:ln>
+        </p:spPr>
+        <p:style>
+          <a:lnRef idx="1">
+            <a:schemeClr val="accent1"/>
+          </a:lnRef>
+          <a:fillRef idx="3">
+            <a:schemeClr val="accent1"/>
+          </a:fillRef>
+          <a:effectRef idx="2">
+            <a:schemeClr val="accent1"/>
+          </a:effectRef>
+          <a:fontRef idx="minor">
+            <a:schemeClr val="lt1"/>
+          </a:fontRef>
+        </p:style>
+        <p:txBody>
+          <a:bodyPr rtlCol="0" anchor="ctr"/>
+          <a:lstStyle/>
+          <a:p>
+            <a:pPr algn="ctr"/>
+          </a:p>
+        </p:txBody>
+      </p:sp>
+      <p:sp>
+        <p:nvSpPr>
+          <p:cNvPr id="17" name="TextBox 16"/>
+          <p:cNvSpPr txBox="1"/>
+          <p:nvPr/>
+        </p:nvSpPr>
+        <p:spPr>
+          <a:xfrm>
+            <a:off x="3233928" y="941832"/>
+            <a:ext cx="548640" cy="146304"/>
+          </a:xfrm>
+          <a:prstGeom prst="rect">
+            <a:avLst/>
+          </a:prstGeom>
+          <a:noFill/>
+        </p:spPr>
+        <p:txBody>
+          <a:bodyPr wrap="square">
+            <a:spAutoFit/>
+          </a:bodyPr>
+          <a:lstStyle/>
+          <a:p>
+            <a:pPr algn="ctr"/>
+            <a:r>
+              <a:rPr sz="700" b="0">
+                <a:solidFill>
+                  <a:srgbClr val="000000"/>
+                </a:solidFill>
+                <a:latin typeface="Arial"/>
+              </a:rPr>
+              <a:t>3.5d</a:t>
+            </a:r>
+          </a:p>
+        </p:txBody>
+      </p:sp>
+      <p:sp>
+        <p:nvSpPr>
+          <p:cNvPr id="18" name="Oval 17"/>
+          <p:cNvSpPr/>
+          <p:nvPr/>
+        </p:nvSpPr>
+        <p:spPr>
+          <a:xfrm>
+            <a:off x="4250131" y="830275"/>
+            <a:ext cx="76809" cy="76809"/>
+          </a:xfrm>
+          <a:prstGeom prst="ellipse">
+            <a:avLst/>
+          </a:prstGeom>
+          <a:solidFill>
+            <a:srgbClr val="000000"/>
+          </a:solidFill>
+          <a:ln>
+            <a:noFill/>
+          </a:ln>
+        </p:spPr>
+        <p:style>
+          <a:lnRef idx="1">
+            <a:schemeClr val="accent1"/>
+          </a:lnRef>
+          <a:fillRef idx="3">
+            <a:schemeClr val="accent1"/>
+          </a:fillRef>
+          <a:effectRef idx="2">
+            <a:schemeClr val="accent1"/>
+          </a:effectRef>
+          <a:fontRef idx="minor">
+            <a:schemeClr val="lt1"/>
+          </a:fontRef>
+        </p:style>
+        <p:txBody>
+          <a:bodyPr rtlCol="0" anchor="ctr"/>
+          <a:lstStyle/>
+          <a:p>
+            <a:pPr algn="ctr"/>
+          </a:p>
+        </p:txBody>
+      </p:sp>
+      <p:sp>
+        <p:nvSpPr>
+          <p:cNvPr id="19" name="TextBox 18"/>
+          <p:cNvSpPr txBox="1"/>
+          <p:nvPr/>
+        </p:nvSpPr>
+        <p:spPr>
+          <a:xfrm>
+            <a:off x="4014215" y="941832"/>
+            <a:ext cx="548640" cy="146304"/>
+          </a:xfrm>
+          <a:prstGeom prst="rect">
+            <a:avLst/>
+          </a:prstGeom>
+          <a:noFill/>
+        </p:spPr>
+        <p:txBody>
+          <a:bodyPr wrap="square">
+            <a:spAutoFit/>
+          </a:bodyPr>
+          <a:lstStyle/>
+          <a:p>
+            <a:pPr algn="ctr"/>
+            <a:r>
+              <a:rPr sz="700" b="0">
+                <a:solidFill>
+                  <a:srgbClr val="000000"/>
+                </a:solidFill>
+                <a:latin typeface="Arial"/>
+              </a:rPr>
+              <a:t>4.5d</a:t>
+            </a:r>
+          </a:p>
+        </p:txBody>
+      </p:sp>
+      <p:sp>
+        <p:nvSpPr>
+          <p:cNvPr id="20" name="Oval 19"/>
+          <p:cNvSpPr/>
+          <p:nvPr/>
+        </p:nvSpPr>
+        <p:spPr>
+          <a:xfrm>
+            <a:off x="5030419" y="830275"/>
+            <a:ext cx="76809" cy="76809"/>
+          </a:xfrm>
+          <a:prstGeom prst="ellipse">
+            <a:avLst/>
+          </a:prstGeom>
+          <a:solidFill>
+            <a:srgbClr val="000000"/>
+          </a:solidFill>
+          <a:ln>
+            <a:noFill/>
+          </a:ln>
+        </p:spPr>
+        <p:style>
+          <a:lnRef idx="1">
+            <a:schemeClr val="accent1"/>
+          </a:lnRef>
+          <a:fillRef idx="3">
+            <a:schemeClr val="accent1"/>
+          </a:fillRef>
+          <a:effectRef idx="2">
+            <a:schemeClr val="accent1"/>
+          </a:effectRef>
+          <a:fontRef idx="minor">
+            <a:schemeClr val="lt1"/>
+          </a:fontRef>
+        </p:style>
+        <p:txBody>
+          <a:bodyPr rtlCol="0" anchor="ctr"/>
+          <a:lstStyle/>
+          <a:p>
+            <a:pPr algn="ctr"/>
+          </a:p>
+        </p:txBody>
+      </p:sp>
+      <p:sp>
+        <p:nvSpPr>
+          <p:cNvPr id="21" name="TextBox 20"/>
+          <p:cNvSpPr txBox="1"/>
+          <p:nvPr/>
+        </p:nvSpPr>
+        <p:spPr>
+          <a:xfrm>
+            <a:off x="4794504" y="941832"/>
+            <a:ext cx="548640" cy="146304"/>
+          </a:xfrm>
+          <a:prstGeom prst="rect">
+            <a:avLst/>
+          </a:prstGeom>
+          <a:noFill/>
+        </p:spPr>
+        <p:txBody>
+          <a:bodyPr wrap="square">
+            <a:spAutoFit/>
+          </a:bodyPr>
+          <a:lstStyle/>
+          <a:p>
+            <a:pPr algn="ctr"/>
+            <a:r>
+              <a:rPr sz="700" b="0">
+                <a:solidFill>
+                  <a:srgbClr val="000000"/>
+                </a:solidFill>
+                <a:latin typeface="Arial"/>
+              </a:rPr>
+              <a:t>5.5d</a:t>
+            </a:r>
+          </a:p>
+        </p:txBody>
+      </p:sp>
+      <p:sp>
+        <p:nvSpPr>
+          <p:cNvPr id="22" name="Oval 21"/>
+          <p:cNvSpPr/>
+          <p:nvPr/>
+        </p:nvSpPr>
+        <p:spPr>
+          <a:xfrm>
+            <a:off x="5810707" y="830275"/>
+            <a:ext cx="76809" cy="76809"/>
+          </a:xfrm>
+          <a:prstGeom prst="ellipse">
+            <a:avLst/>
+          </a:prstGeom>
+          <a:solidFill>
+            <a:srgbClr val="000000"/>
+          </a:solidFill>
+          <a:ln>
+            <a:noFill/>
+          </a:ln>
+        </p:spPr>
+        <p:style>
+          <a:lnRef idx="1">
+            <a:schemeClr val="accent1"/>
+          </a:lnRef>
+          <a:fillRef idx="3">
+            <a:schemeClr val="accent1"/>
+          </a:fillRef>
+          <a:effectRef idx="2">
+            <a:schemeClr val="accent1"/>
+          </a:effectRef>
+          <a:fontRef idx="minor">
+            <a:schemeClr val="lt1"/>
+          </a:fontRef>
+        </p:style>
+        <p:txBody>
+          <a:bodyPr rtlCol="0" anchor="ctr"/>
+          <a:lstStyle/>
+          <a:p>
+            <a:pPr algn="ctr"/>
+          </a:p>
+        </p:txBody>
+      </p:sp>
+      <p:sp>
+        <p:nvSpPr>
+          <p:cNvPr id="23" name="TextBox 22"/>
+          <p:cNvSpPr txBox="1"/>
+          <p:nvPr/>
+        </p:nvSpPr>
+        <p:spPr>
+          <a:xfrm>
+            <a:off x="5574792" y="941832"/>
+            <a:ext cx="548640" cy="146304"/>
+          </a:xfrm>
+          <a:prstGeom prst="rect">
+            <a:avLst/>
+          </a:prstGeom>
+          <a:noFill/>
+        </p:spPr>
+        <p:txBody>
+          <a:bodyPr wrap="square">
+            <a:spAutoFit/>
+          </a:bodyPr>
+          <a:lstStyle/>
+          <a:p>
+            <a:pPr algn="ctr"/>
+            <a:r>
+              <a:rPr sz="700" b="0">
+                <a:solidFill>
+                  <a:srgbClr val="000000"/>
+                </a:solidFill>
+                <a:latin typeface="Arial"/>
+              </a:rPr>
+              <a:t>6.5d</a:t>
+            </a:r>
+          </a:p>
+        </p:txBody>
+      </p:sp>
+      <p:sp>
+        <p:nvSpPr>
+          <p:cNvPr id="24" name="Oval 23"/>
+          <p:cNvSpPr/>
+          <p:nvPr/>
+        </p:nvSpPr>
+        <p:spPr>
+          <a:xfrm>
+            <a:off x="6590995" y="830275"/>
+            <a:ext cx="76809" cy="76809"/>
+          </a:xfrm>
+          <a:prstGeom prst="ellipse">
+            <a:avLst/>
+          </a:prstGeom>
+          <a:solidFill>
+            <a:srgbClr val="000000"/>
+          </a:solidFill>
+          <a:ln>
+            <a:noFill/>
+          </a:ln>
+        </p:spPr>
+        <p:style>
+          <a:lnRef idx="1">
+            <a:schemeClr val="accent1"/>
+          </a:lnRef>
+          <a:fillRef idx="3">
+            <a:schemeClr val="accent1"/>
+          </a:fillRef>
+          <a:effectRef idx="2">
+            <a:schemeClr val="accent1"/>
+          </a:effectRef>
+          <a:fontRef idx="minor">
+            <a:schemeClr val="lt1"/>
+          </a:fontRef>
+        </p:style>
+        <p:txBody>
+          <a:bodyPr rtlCol="0" anchor="ctr"/>
+          <a:lstStyle/>
+          <a:p>
+            <a:pPr algn="ctr"/>
+          </a:p>
+        </p:txBody>
+      </p:sp>
+      <p:sp>
+        <p:nvSpPr>
+          <p:cNvPr id="25" name="TextBox 24"/>
+          <p:cNvSpPr txBox="1"/>
+          <p:nvPr/>
+        </p:nvSpPr>
+        <p:spPr>
+          <a:xfrm>
+            <a:off x="6355080" y="941832"/>
+            <a:ext cx="548640" cy="146304"/>
+          </a:xfrm>
+          <a:prstGeom prst="rect">
+            <a:avLst/>
+          </a:prstGeom>
+          <a:noFill/>
+        </p:spPr>
+        <p:txBody>
+          <a:bodyPr wrap="square">
+            <a:spAutoFit/>
+          </a:bodyPr>
+          <a:lstStyle/>
+          <a:p>
+            <a:pPr algn="ctr"/>
+            <a:r>
+              <a:rPr sz="700" b="0">
+                <a:solidFill>
+                  <a:srgbClr val="000000"/>
+                </a:solidFill>
+                <a:latin typeface="Arial"/>
+              </a:rPr>
+              <a:t>7.5d</a:t>
+            </a:r>
+          </a:p>
+        </p:txBody>
+      </p:sp>
+      <p:cxnSp>
+        <p:nvCxnSpPr>
+          <p:cNvPr id="26" name="Connector 25"/>
+          <p:cNvCxnSpPr/>
+          <p:nvPr/>
+        </p:nvCxnSpPr>
+        <p:spPr>
+          <a:xfrm>
+            <a:off x="1947672" y="918057"/>
+            <a:ext cx="0" cy="499263"/>
+          </a:xfrm>
+          <a:prstGeom prst="line">
+            <a:avLst/>
+          </a:prstGeom>
+          <a:ln w="13970">
+            <a:solidFill>
+              <a:srgbClr val="000000"/>
+            </a:solidFill>
+            <a:prstDash val="dash"/>
           </a:ln>
         </p:spPr>
         <p:style>
@@ -3413,19 +4022,19 @@
       </p:cxnSp>
       <p:cxnSp>
         <p:nvCxnSpPr>
-          <p:cNvPr id="11" name="Connector 10"/>
+          <p:cNvPr id="27" name="Connector 26"/>
           <p:cNvCxnSpPr/>
           <p:nvPr/>
         </p:nvCxnSpPr>
         <p:spPr>
           <a:xfrm>
-            <a:off x="640080" y="1453896"/>
-            <a:ext cx="777240" cy="0"/>
+            <a:off x="1947672" y="1417320"/>
+            <a:ext cx="1560576" cy="0"/>
           </a:xfrm>
           <a:prstGeom prst="line">
             <a:avLst/>
           </a:prstGeom>
-          <a:ln w="14604">
+          <a:ln w="18415">
             <a:solidFill>
               <a:srgbClr val="000000"/>
             </a:solidFill>
@@ -3448,632 +4057,22 @@
       </p:cxnSp>
       <p:cxnSp>
         <p:nvCxnSpPr>
-          <p:cNvPr id="12" name="Connector 11"/>
-          <p:cNvCxnSpPr/>
-          <p:nvPr/>
-        </p:nvCxnSpPr>
-        <p:spPr>
-          <a:xfrm>
-            <a:off x="1417320" y="1362456"/>
-            <a:ext cx="0" cy="91440"/>
-          </a:xfrm>
-          <a:prstGeom prst="line">
-            <a:avLst/>
-          </a:prstGeom>
-          <a:ln w="14604">
-            <a:solidFill>
-              <a:srgbClr val="000000"/>
-            </a:solidFill>
-          </a:ln>
-        </p:spPr>
-        <p:style>
-          <a:lnRef idx="2">
-            <a:schemeClr val="accent1"/>
-          </a:lnRef>
-          <a:fillRef idx="0">
-            <a:schemeClr val="accent1"/>
-          </a:fillRef>
-          <a:effectRef idx="1">
-            <a:schemeClr val="accent1"/>
-          </a:effectRef>
-          <a:fontRef idx="minor">
-            <a:schemeClr val="tx1"/>
-          </a:fontRef>
-        </p:style>
-      </p:cxnSp>
-      <p:sp>
-        <p:nvSpPr>
-          <p:cNvPr id="13" name="TextBox 12"/>
-          <p:cNvSpPr txBox="1"/>
-          <p:nvPr/>
-        </p:nvSpPr>
-        <p:spPr>
-          <a:xfrm>
-            <a:off x="594359" y="1472184"/>
-            <a:ext cx="868680" cy="201168"/>
-          </a:xfrm>
-          <a:prstGeom prst="rect">
-            <a:avLst/>
-          </a:prstGeom>
-          <a:noFill/>
-        </p:spPr>
-        <p:txBody>
-          <a:bodyPr wrap="square">
-            <a:spAutoFit/>
-          </a:bodyPr>
-          <a:lstStyle/>
-          <a:p>
-            <a:pPr algn="ctr"/>
-            <a:r>
-              <a:rPr sz="900" b="0">
-                <a:solidFill>
-                  <a:srgbClr val="000000"/>
-                </a:solidFill>
-                <a:latin typeface="Arial"/>
-              </a:rPr>
-              <a:t>(CA)</a:t>
-            </a:r>
-          </a:p>
-        </p:txBody>
-      </p:sp>
-      <p:sp>
-        <p:nvSpPr>
-          <p:cNvPr id="14" name="Oval 13"/>
-          <p:cNvSpPr/>
-          <p:nvPr/>
-        </p:nvSpPr>
-        <p:spPr>
-          <a:xfrm>
-            <a:off x="2009851" y="1186891"/>
-            <a:ext cx="95097" cy="95097"/>
-          </a:xfrm>
-          <a:prstGeom prst="ellipse">
-            <a:avLst/>
-          </a:prstGeom>
-          <a:solidFill>
-            <a:srgbClr val="000000"/>
-          </a:solidFill>
-          <a:ln>
-            <a:noFill/>
-          </a:ln>
-        </p:spPr>
-        <p:style>
-          <a:lnRef idx="1">
-            <a:schemeClr val="accent1"/>
-          </a:lnRef>
-          <a:fillRef idx="3">
-            <a:schemeClr val="accent1"/>
-          </a:fillRef>
-          <a:effectRef idx="2">
-            <a:schemeClr val="accent1"/>
-          </a:effectRef>
-          <a:fontRef idx="minor">
-            <a:schemeClr val="lt1"/>
-          </a:fontRef>
-        </p:style>
-        <p:txBody>
-          <a:bodyPr rtlCol="0" anchor="ctr"/>
-          <a:lstStyle/>
-          <a:p>
-            <a:pPr algn="ctr"/>
-          </a:p>
-        </p:txBody>
-      </p:sp>
-      <p:sp>
-        <p:nvSpPr>
-          <p:cNvPr id="15" name="TextBox 14"/>
-          <p:cNvSpPr txBox="1"/>
-          <p:nvPr/>
-        </p:nvSpPr>
-        <p:spPr>
-          <a:xfrm>
-            <a:off x="1737360" y="923544"/>
-            <a:ext cx="640080" cy="219456"/>
-          </a:xfrm>
-          <a:prstGeom prst="rect">
-            <a:avLst/>
-          </a:prstGeom>
-          <a:noFill/>
-        </p:spPr>
-        <p:txBody>
-          <a:bodyPr wrap="square">
-            <a:spAutoFit/>
-          </a:bodyPr>
-          <a:lstStyle/>
-          <a:p>
-            <a:pPr algn="ctr"/>
-            <a:r>
-              <a:rPr sz="1000" b="1">
-                <a:solidFill>
-                  <a:srgbClr val="000000"/>
-                </a:solidFill>
-                <a:latin typeface="Arial"/>
-              </a:rPr>
-              <a:t>BMP</a:t>
-            </a:r>
-          </a:p>
-        </p:txBody>
-      </p:sp>
-      <p:cxnSp>
-        <p:nvCxnSpPr>
-          <p:cNvPr id="16" name="Connector 15"/>
-          <p:cNvCxnSpPr/>
-          <p:nvPr/>
-        </p:nvCxnSpPr>
-        <p:spPr>
-          <a:xfrm>
-            <a:off x="2697480" y="1133856"/>
-            <a:ext cx="0" cy="201168"/>
-          </a:xfrm>
-          <a:prstGeom prst="line">
-            <a:avLst/>
-          </a:prstGeom>
-          <a:ln w="14604">
-            <a:solidFill>
-              <a:srgbClr val="000000"/>
-            </a:solidFill>
-          </a:ln>
-        </p:spPr>
-        <p:style>
-          <a:lnRef idx="2">
-            <a:schemeClr val="accent1"/>
-          </a:lnRef>
-          <a:fillRef idx="0">
-            <a:schemeClr val="accent1"/>
-          </a:fillRef>
-          <a:effectRef idx="1">
-            <a:schemeClr val="accent1"/>
-          </a:effectRef>
-          <a:fontRef idx="minor">
-            <a:schemeClr val="tx1"/>
-          </a:fontRef>
-        </p:style>
-      </p:cxnSp>
-      <p:sp>
-        <p:nvSpPr>
-          <p:cNvPr id="17" name="TextBox 16"/>
-          <p:cNvSpPr txBox="1"/>
-          <p:nvPr/>
-        </p:nvSpPr>
-        <p:spPr>
-          <a:xfrm>
-            <a:off x="2468880" y="1344168"/>
-            <a:ext cx="457200" cy="201168"/>
-          </a:xfrm>
-          <a:prstGeom prst="rect">
-            <a:avLst/>
-          </a:prstGeom>
-          <a:noFill/>
-        </p:spPr>
-        <p:txBody>
-          <a:bodyPr wrap="square">
-            <a:spAutoFit/>
-          </a:bodyPr>
-          <a:lstStyle/>
-          <a:p>
-            <a:pPr algn="ctr"/>
-            <a:r>
-              <a:rPr sz="900" b="0">
-                <a:solidFill>
-                  <a:srgbClr val="000000"/>
-                </a:solidFill>
-                <a:latin typeface="Arial"/>
-              </a:rPr>
-              <a:t>2S</a:t>
-            </a:r>
-          </a:p>
-        </p:txBody>
-      </p:sp>
-      <p:sp>
-        <p:nvSpPr>
-          <p:cNvPr id="18" name="TextBox 17"/>
-          <p:cNvSpPr txBox="1"/>
-          <p:nvPr/>
-        </p:nvSpPr>
-        <p:spPr>
-          <a:xfrm>
-            <a:off x="2834640" y="868680"/>
-            <a:ext cx="3428999" cy="219456"/>
-          </a:xfrm>
-          <a:prstGeom prst="rect">
-            <a:avLst/>
-          </a:prstGeom>
-          <a:noFill/>
-        </p:spPr>
-        <p:txBody>
-          <a:bodyPr wrap="square">
-            <a:spAutoFit/>
-          </a:bodyPr>
-          <a:lstStyle/>
-          <a:p>
-            <a:pPr algn="ctr"/>
-            <a:r>
-              <a:rPr sz="1000" b="1">
-                <a:solidFill>
-                  <a:srgbClr val="000000"/>
-                </a:solidFill>
-                <a:latin typeface="Arial"/>
-              </a:rPr>
-              <a:t>BMP + SCF + EGF</a:t>
-            </a:r>
-          </a:p>
-        </p:txBody>
-      </p:sp>
-      <p:sp>
-        <p:nvSpPr>
-          <p:cNvPr id="19" name="Oval 18"/>
-          <p:cNvSpPr/>
-          <p:nvPr/>
-        </p:nvSpPr>
-        <p:spPr>
-          <a:xfrm>
-            <a:off x="3198571" y="1186891"/>
-            <a:ext cx="95097" cy="95097"/>
-          </a:xfrm>
-          <a:prstGeom prst="ellipse">
-            <a:avLst/>
-          </a:prstGeom>
-          <a:solidFill>
-            <a:srgbClr val="000000"/>
-          </a:solidFill>
-          <a:ln>
-            <a:noFill/>
-          </a:ln>
-        </p:spPr>
-        <p:style>
-          <a:lnRef idx="1">
-            <a:schemeClr val="accent1"/>
-          </a:lnRef>
-          <a:fillRef idx="3">
-            <a:schemeClr val="accent1"/>
-          </a:fillRef>
-          <a:effectRef idx="2">
-            <a:schemeClr val="accent1"/>
-          </a:effectRef>
-          <a:fontRef idx="minor">
-            <a:schemeClr val="lt1"/>
-          </a:fontRef>
-        </p:style>
-        <p:txBody>
-          <a:bodyPr rtlCol="0" anchor="ctr"/>
-          <a:lstStyle/>
-          <a:p>
-            <a:pPr algn="ctr"/>
-          </a:p>
-        </p:txBody>
-      </p:sp>
-      <p:sp>
-        <p:nvSpPr>
-          <p:cNvPr id="20" name="Oval 19"/>
-          <p:cNvSpPr/>
-          <p:nvPr/>
-        </p:nvSpPr>
-        <p:spPr>
-          <a:xfrm>
-            <a:off x="4021531" y="1186891"/>
-            <a:ext cx="95097" cy="95097"/>
-          </a:xfrm>
-          <a:prstGeom prst="ellipse">
-            <a:avLst/>
-          </a:prstGeom>
-          <a:solidFill>
-            <a:srgbClr val="000000"/>
-          </a:solidFill>
-          <a:ln>
-            <a:noFill/>
-          </a:ln>
-        </p:spPr>
-        <p:style>
-          <a:lnRef idx="1">
-            <a:schemeClr val="accent1"/>
-          </a:lnRef>
-          <a:fillRef idx="3">
-            <a:schemeClr val="accent1"/>
-          </a:fillRef>
-          <a:effectRef idx="2">
-            <a:schemeClr val="accent1"/>
-          </a:effectRef>
-          <a:fontRef idx="minor">
-            <a:schemeClr val="lt1"/>
-          </a:fontRef>
-        </p:style>
-        <p:txBody>
-          <a:bodyPr rtlCol="0" anchor="ctr"/>
-          <a:lstStyle/>
-          <a:p>
-            <a:pPr algn="ctr"/>
-          </a:p>
-        </p:txBody>
-      </p:sp>
-      <p:sp>
-        <p:nvSpPr>
-          <p:cNvPr id="21" name="Oval 20"/>
-          <p:cNvSpPr/>
-          <p:nvPr/>
-        </p:nvSpPr>
-        <p:spPr>
-          <a:xfrm>
-            <a:off x="4844491" y="1186891"/>
-            <a:ext cx="95097" cy="95097"/>
-          </a:xfrm>
-          <a:prstGeom prst="ellipse">
-            <a:avLst/>
-          </a:prstGeom>
-          <a:solidFill>
-            <a:srgbClr val="000000"/>
-          </a:solidFill>
-          <a:ln>
-            <a:noFill/>
-          </a:ln>
-        </p:spPr>
-        <p:style>
-          <a:lnRef idx="1">
-            <a:schemeClr val="accent1"/>
-          </a:lnRef>
-          <a:fillRef idx="3">
-            <a:schemeClr val="accent1"/>
-          </a:fillRef>
-          <a:effectRef idx="2">
-            <a:schemeClr val="accent1"/>
-          </a:effectRef>
-          <a:fontRef idx="minor">
-            <a:schemeClr val="lt1"/>
-          </a:fontRef>
-        </p:style>
-        <p:txBody>
-          <a:bodyPr rtlCol="0" anchor="ctr"/>
-          <a:lstStyle/>
-          <a:p>
-            <a:pPr algn="ctr"/>
-          </a:p>
-        </p:txBody>
-      </p:sp>
-      <p:sp>
-        <p:nvSpPr>
-          <p:cNvPr id="22" name="Oval 21"/>
-          <p:cNvSpPr/>
-          <p:nvPr/>
-        </p:nvSpPr>
-        <p:spPr>
-          <a:xfrm>
-            <a:off x="5667451" y="1186891"/>
-            <a:ext cx="95097" cy="95097"/>
-          </a:xfrm>
-          <a:prstGeom prst="ellipse">
-            <a:avLst/>
-          </a:prstGeom>
-          <a:solidFill>
-            <a:srgbClr val="000000"/>
-          </a:solidFill>
-          <a:ln>
-            <a:noFill/>
-          </a:ln>
-        </p:spPr>
-        <p:style>
-          <a:lnRef idx="1">
-            <a:schemeClr val="accent1"/>
-          </a:lnRef>
-          <a:fillRef idx="3">
-            <a:schemeClr val="accent1"/>
-          </a:fillRef>
-          <a:effectRef idx="2">
-            <a:schemeClr val="accent1"/>
-          </a:effectRef>
-          <a:fontRef idx="minor">
-            <a:schemeClr val="lt1"/>
-          </a:fontRef>
-        </p:style>
-        <p:txBody>
-          <a:bodyPr rtlCol="0" anchor="ctr"/>
-          <a:lstStyle/>
-          <a:p>
-            <a:pPr algn="ctr"/>
-          </a:p>
-        </p:txBody>
-      </p:sp>
-      <p:cxnSp>
-        <p:nvCxnSpPr>
-          <p:cNvPr id="23" name="Connector 22"/>
-          <p:cNvCxnSpPr/>
-          <p:nvPr/>
-        </p:nvCxnSpPr>
-        <p:spPr>
-          <a:xfrm>
-            <a:off x="3246120" y="1300276"/>
-            <a:ext cx="0" cy="711404"/>
-          </a:xfrm>
-          <a:prstGeom prst="line">
-            <a:avLst/>
-          </a:prstGeom>
-          <a:ln w="14604">
-            <a:solidFill>
-              <a:srgbClr val="000000"/>
-            </a:solidFill>
-            <a:prstDash val="dash"/>
-          </a:ln>
-        </p:spPr>
-        <p:style>
-          <a:lnRef idx="2">
-            <a:schemeClr val="accent1"/>
-          </a:lnRef>
-          <a:fillRef idx="0">
-            <a:schemeClr val="accent1"/>
-          </a:fillRef>
-          <a:effectRef idx="1">
-            <a:schemeClr val="accent1"/>
-          </a:effectRef>
-          <a:fontRef idx="minor">
-            <a:schemeClr val="tx1"/>
-          </a:fontRef>
-        </p:style>
-      </p:cxnSp>
-      <p:cxnSp>
-        <p:nvCxnSpPr>
-          <p:cNvPr id="24" name="Connector 23"/>
-          <p:cNvCxnSpPr/>
-          <p:nvPr/>
-        </p:nvCxnSpPr>
-        <p:spPr>
-          <a:xfrm>
-            <a:off x="3246120" y="2011680"/>
-            <a:ext cx="640080" cy="0"/>
-          </a:xfrm>
-          <a:prstGeom prst="line">
-            <a:avLst/>
-          </a:prstGeom>
-          <a:ln w="19050">
-            <a:solidFill>
-              <a:srgbClr val="000000"/>
-            </a:solidFill>
-          </a:ln>
-        </p:spPr>
-        <p:style>
-          <a:lnRef idx="2">
-            <a:schemeClr val="accent1"/>
-          </a:lnRef>
-          <a:fillRef idx="0">
-            <a:schemeClr val="accent1"/>
-          </a:fillRef>
-          <a:effectRef idx="1">
-            <a:schemeClr val="accent1"/>
-          </a:effectRef>
-          <a:fontRef idx="minor">
-            <a:schemeClr val="tx1"/>
-          </a:fontRef>
-        </p:style>
-      </p:cxnSp>
-      <p:cxnSp>
-        <p:nvCxnSpPr>
-          <p:cNvPr id="25" name="Connector 24"/>
-          <p:cNvCxnSpPr/>
-          <p:nvPr/>
-        </p:nvCxnSpPr>
-        <p:spPr>
-          <a:xfrm>
-            <a:off x="3207258" y="1972818"/>
-            <a:ext cx="77724" cy="77724"/>
-          </a:xfrm>
-          <a:prstGeom prst="line">
-            <a:avLst/>
-          </a:prstGeom>
-          <a:ln w="19050">
-            <a:solidFill>
-              <a:srgbClr val="000000"/>
-            </a:solidFill>
-          </a:ln>
-        </p:spPr>
-        <p:style>
-          <a:lnRef idx="2">
-            <a:schemeClr val="accent1"/>
-          </a:lnRef>
-          <a:fillRef idx="0">
-            <a:schemeClr val="accent1"/>
-          </a:fillRef>
-          <a:effectRef idx="1">
-            <a:schemeClr val="accent1"/>
-          </a:effectRef>
-          <a:fontRef idx="minor">
-            <a:schemeClr val="tx1"/>
-          </a:fontRef>
-        </p:style>
-      </p:cxnSp>
-      <p:cxnSp>
-        <p:nvCxnSpPr>
-          <p:cNvPr id="26" name="Connector 25"/>
-          <p:cNvCxnSpPr/>
-          <p:nvPr/>
-        </p:nvCxnSpPr>
-        <p:spPr>
-          <a:xfrm flipV="1">
-            <a:off x="3207258" y="1972818"/>
-            <a:ext cx="77724" cy="77724"/>
-          </a:xfrm>
-          <a:prstGeom prst="line">
-            <a:avLst/>
-          </a:prstGeom>
-          <a:ln w="19050">
-            <a:solidFill>
-              <a:srgbClr val="000000"/>
-            </a:solidFill>
-          </a:ln>
-        </p:spPr>
-        <p:style>
-          <a:lnRef idx="2">
-            <a:schemeClr val="accent1"/>
-          </a:lnRef>
-          <a:fillRef idx="0">
-            <a:schemeClr val="accent1"/>
-          </a:fillRef>
-          <a:effectRef idx="1">
-            <a:schemeClr val="accent1"/>
-          </a:effectRef>
-          <a:fontRef idx="minor">
-            <a:schemeClr val="tx1"/>
-          </a:fontRef>
-        </p:style>
-      </p:cxnSp>
-      <p:sp>
-        <p:nvSpPr>
-          <p:cNvPr id="27" name="Oval 26"/>
-          <p:cNvSpPr/>
-          <p:nvPr/>
-        </p:nvSpPr>
-        <p:spPr>
-          <a:xfrm>
-            <a:off x="3838651" y="1964131"/>
-            <a:ext cx="95097" cy="95097"/>
-          </a:xfrm>
-          <a:prstGeom prst="ellipse">
-            <a:avLst/>
-          </a:prstGeom>
-          <a:solidFill>
-            <a:srgbClr val="000000"/>
-          </a:solidFill>
-          <a:ln>
-            <a:noFill/>
-          </a:ln>
-        </p:spPr>
-        <p:style>
-          <a:lnRef idx="1">
-            <a:schemeClr val="accent1"/>
-          </a:lnRef>
-          <a:fillRef idx="3">
-            <a:schemeClr val="accent1"/>
-          </a:fillRef>
-          <a:effectRef idx="2">
-            <a:schemeClr val="accent1"/>
-          </a:effectRef>
-          <a:fontRef idx="minor">
-            <a:schemeClr val="lt1"/>
-          </a:fontRef>
-        </p:style>
-        <p:txBody>
-          <a:bodyPr rtlCol="0" anchor="ctr"/>
-          <a:lstStyle/>
-          <a:p>
-            <a:pPr algn="ctr"/>
-          </a:p>
-        </p:txBody>
-      </p:sp>
-      <p:cxnSp>
-        <p:nvCxnSpPr>
           <p:cNvPr id="28" name="Connector 27"/>
           <p:cNvCxnSpPr/>
           <p:nvPr/>
         </p:nvCxnSpPr>
         <p:spPr>
           <a:xfrm>
-            <a:off x="4069080" y="1300276"/>
-            <a:ext cx="0" cy="1305764"/>
+            <a:off x="1915668" y="1385316"/>
+            <a:ext cx="64008" cy="64008"/>
           </a:xfrm>
           <a:prstGeom prst="line">
             <a:avLst/>
           </a:prstGeom>
-          <a:ln w="14604">
+          <a:ln w="18415">
             <a:solidFill>
               <a:srgbClr val="000000"/>
             </a:solidFill>
-            <a:prstDash val="dash"/>
           </a:ln>
         </p:spPr>
         <p:style>
@@ -4098,17 +4097,96 @@
           <p:nvPr/>
         </p:nvCxnSpPr>
         <p:spPr>
-          <a:xfrm>
-            <a:off x="4069080" y="2606040"/>
-            <a:ext cx="640080" cy="0"/>
+          <a:xfrm flipV="1">
+            <a:off x="1915668" y="1385316"/>
+            <a:ext cx="64008" cy="64008"/>
           </a:xfrm>
           <a:prstGeom prst="line">
             <a:avLst/>
           </a:prstGeom>
-          <a:ln w="19050">
+          <a:ln w="18415">
             <a:solidFill>
               <a:srgbClr val="000000"/>
             </a:solidFill>
+          </a:ln>
+        </p:spPr>
+        <p:style>
+          <a:lnRef idx="2">
+            <a:schemeClr val="accent1"/>
+          </a:lnRef>
+          <a:fillRef idx="0">
+            <a:schemeClr val="accent1"/>
+          </a:fillRef>
+          <a:effectRef idx="1">
+            <a:schemeClr val="accent1"/>
+          </a:effectRef>
+          <a:fontRef idx="minor">
+            <a:schemeClr val="tx1"/>
+          </a:fontRef>
+        </p:style>
+      </p:cxnSp>
+      <p:sp>
+        <p:nvSpPr>
+          <p:cNvPr id="30" name="Oval 29"/>
+          <p:cNvSpPr/>
+          <p:nvPr/>
+        </p:nvSpPr>
+        <p:spPr>
+          <a:xfrm>
+            <a:off x="3469843" y="1378915"/>
+            <a:ext cx="76809" cy="76809"/>
+          </a:xfrm>
+          <a:prstGeom prst="ellipse">
+            <a:avLst/>
+          </a:prstGeom>
+          <a:solidFill>
+            <a:srgbClr val="000000"/>
+          </a:solidFill>
+          <a:ln>
+            <a:noFill/>
+          </a:ln>
+        </p:spPr>
+        <p:style>
+          <a:lnRef idx="1">
+            <a:schemeClr val="accent1"/>
+          </a:lnRef>
+          <a:fillRef idx="3">
+            <a:schemeClr val="accent1"/>
+          </a:fillRef>
+          <a:effectRef idx="2">
+            <a:schemeClr val="accent1"/>
+          </a:effectRef>
+          <a:fontRef idx="minor">
+            <a:schemeClr val="lt1"/>
+          </a:fontRef>
+        </p:style>
+        <p:txBody>
+          <a:bodyPr rtlCol="0" anchor="ctr"/>
+          <a:lstStyle/>
+          <a:p>
+            <a:pPr algn="ctr"/>
+          </a:p>
+        </p:txBody>
+      </p:sp>
+      <p:cxnSp>
+        <p:nvCxnSpPr>
+          <p:cNvPr id="31" name="Connector 30"/>
+          <p:cNvCxnSpPr/>
+          <p:nvPr/>
+        </p:nvCxnSpPr>
+        <p:spPr>
+          <a:xfrm>
+            <a:off x="2727960" y="918057"/>
+            <a:ext cx="0" cy="865023"/>
+          </a:xfrm>
+          <a:prstGeom prst="line">
+            <a:avLst/>
+          </a:prstGeom>
+          <a:ln w="13970">
+            <a:solidFill>
+              <a:srgbClr val="000000"/>
+            </a:solidFill>
+            <a:prstDash val="dash"/>
           </a:ln>
         </p:spPr>
         <p:style>
@@ -4128,19 +4206,19 @@
       </p:cxnSp>
       <p:cxnSp>
         <p:nvCxnSpPr>
-          <p:cNvPr id="30" name="Connector 29"/>
+          <p:cNvPr id="32" name="Connector 31"/>
           <p:cNvCxnSpPr/>
           <p:nvPr/>
         </p:nvCxnSpPr>
         <p:spPr>
           <a:xfrm>
-            <a:off x="4030218" y="2567178"/>
-            <a:ext cx="77724" cy="77724"/>
+            <a:off x="2727960" y="1783080"/>
+            <a:ext cx="1560576" cy="0"/>
           </a:xfrm>
           <a:prstGeom prst="line">
             <a:avLst/>
           </a:prstGeom>
-          <a:ln w="19050">
+          <a:ln w="18415">
             <a:solidFill>
               <a:srgbClr val="000000"/>
             </a:solidFill>
@@ -4163,101 +4241,22 @@
       </p:cxnSp>
       <p:cxnSp>
         <p:nvCxnSpPr>
-          <p:cNvPr id="31" name="Connector 30"/>
-          <p:cNvCxnSpPr/>
-          <p:nvPr/>
-        </p:nvCxnSpPr>
-        <p:spPr>
-          <a:xfrm flipV="1">
-            <a:off x="4030218" y="2567178"/>
-            <a:ext cx="77724" cy="77724"/>
-          </a:xfrm>
-          <a:prstGeom prst="line">
-            <a:avLst/>
-          </a:prstGeom>
-          <a:ln w="19050">
-            <a:solidFill>
-              <a:srgbClr val="000000"/>
-            </a:solidFill>
-          </a:ln>
-        </p:spPr>
-        <p:style>
-          <a:lnRef idx="2">
-            <a:schemeClr val="accent1"/>
-          </a:lnRef>
-          <a:fillRef idx="0">
-            <a:schemeClr val="accent1"/>
-          </a:fillRef>
-          <a:effectRef idx="1">
-            <a:schemeClr val="accent1"/>
-          </a:effectRef>
-          <a:fontRef idx="minor">
-            <a:schemeClr val="tx1"/>
-          </a:fontRef>
-        </p:style>
-      </p:cxnSp>
-      <p:sp>
-        <p:nvSpPr>
-          <p:cNvPr id="32" name="Oval 31"/>
-          <p:cNvSpPr/>
-          <p:nvPr/>
-        </p:nvSpPr>
-        <p:spPr>
-          <a:xfrm>
-            <a:off x="4661611" y="2558491"/>
-            <a:ext cx="95097" cy="95097"/>
-          </a:xfrm>
-          <a:prstGeom prst="ellipse">
-            <a:avLst/>
-          </a:prstGeom>
-          <a:solidFill>
-            <a:srgbClr val="000000"/>
-          </a:solidFill>
-          <a:ln>
-            <a:noFill/>
-          </a:ln>
-        </p:spPr>
-        <p:style>
-          <a:lnRef idx="1">
-            <a:schemeClr val="accent1"/>
-          </a:lnRef>
-          <a:fillRef idx="3">
-            <a:schemeClr val="accent1"/>
-          </a:fillRef>
-          <a:effectRef idx="2">
-            <a:schemeClr val="accent1"/>
-          </a:effectRef>
-          <a:fontRef idx="minor">
-            <a:schemeClr val="lt1"/>
-          </a:fontRef>
-        </p:style>
-        <p:txBody>
-          <a:bodyPr rtlCol="0" anchor="ctr"/>
-          <a:lstStyle/>
-          <a:p>
-            <a:pPr algn="ctr"/>
-          </a:p>
-        </p:txBody>
-      </p:sp>
-      <p:cxnSp>
-        <p:nvCxnSpPr>
           <p:cNvPr id="33" name="Connector 32"/>
           <p:cNvCxnSpPr/>
           <p:nvPr/>
         </p:nvCxnSpPr>
         <p:spPr>
           <a:xfrm>
-            <a:off x="4892040" y="1300276"/>
-            <a:ext cx="0" cy="1854404"/>
+            <a:off x="2695956" y="1751076"/>
+            <a:ext cx="64008" cy="64008"/>
           </a:xfrm>
           <a:prstGeom prst="line">
             <a:avLst/>
           </a:prstGeom>
-          <a:ln w="14604">
+          <a:ln w="18415">
             <a:solidFill>
               <a:srgbClr val="000000"/>
             </a:solidFill>
-            <a:prstDash val="dash"/>
           </a:ln>
         </p:spPr>
         <p:style>
@@ -4282,17 +4281,96 @@
           <p:nvPr/>
         </p:nvCxnSpPr>
         <p:spPr>
-          <a:xfrm>
-            <a:off x="4892040" y="3154680"/>
-            <a:ext cx="640080" cy="0"/>
+          <a:xfrm flipV="1">
+            <a:off x="2695956" y="1751076"/>
+            <a:ext cx="64008" cy="64008"/>
           </a:xfrm>
           <a:prstGeom prst="line">
             <a:avLst/>
           </a:prstGeom>
-          <a:ln w="19050">
+          <a:ln w="18415">
             <a:solidFill>
               <a:srgbClr val="000000"/>
             </a:solidFill>
+          </a:ln>
+        </p:spPr>
+        <p:style>
+          <a:lnRef idx="2">
+            <a:schemeClr val="accent1"/>
+          </a:lnRef>
+          <a:fillRef idx="0">
+            <a:schemeClr val="accent1"/>
+          </a:fillRef>
+          <a:effectRef idx="1">
+            <a:schemeClr val="accent1"/>
+          </a:effectRef>
+          <a:fontRef idx="minor">
+            <a:schemeClr val="tx1"/>
+          </a:fontRef>
+        </p:style>
+      </p:cxnSp>
+      <p:sp>
+        <p:nvSpPr>
+          <p:cNvPr id="35" name="Oval 34"/>
+          <p:cNvSpPr/>
+          <p:nvPr/>
+        </p:nvSpPr>
+        <p:spPr>
+          <a:xfrm>
+            <a:off x="4250131" y="1744675"/>
+            <a:ext cx="76809" cy="76809"/>
+          </a:xfrm>
+          <a:prstGeom prst="ellipse">
+            <a:avLst/>
+          </a:prstGeom>
+          <a:solidFill>
+            <a:srgbClr val="000000"/>
+          </a:solidFill>
+          <a:ln>
+            <a:noFill/>
+          </a:ln>
+        </p:spPr>
+        <p:style>
+          <a:lnRef idx="1">
+            <a:schemeClr val="accent1"/>
+          </a:lnRef>
+          <a:fillRef idx="3">
+            <a:schemeClr val="accent1"/>
+          </a:fillRef>
+          <a:effectRef idx="2">
+            <a:schemeClr val="accent1"/>
+          </a:effectRef>
+          <a:fontRef idx="minor">
+            <a:schemeClr val="lt1"/>
+          </a:fontRef>
+        </p:style>
+        <p:txBody>
+          <a:bodyPr rtlCol="0" anchor="ctr"/>
+          <a:lstStyle/>
+          <a:p>
+            <a:pPr algn="ctr"/>
+          </a:p>
+        </p:txBody>
+      </p:sp>
+      <p:cxnSp>
+        <p:nvCxnSpPr>
+          <p:cNvPr id="36" name="Connector 35"/>
+          <p:cNvCxnSpPr/>
+          <p:nvPr/>
+        </p:nvCxnSpPr>
+        <p:spPr>
+          <a:xfrm>
+            <a:off x="3508248" y="918057"/>
+            <a:ext cx="0" cy="1230783"/>
+          </a:xfrm>
+          <a:prstGeom prst="line">
+            <a:avLst/>
+          </a:prstGeom>
+          <a:ln w="13970">
+            <a:solidFill>
+              <a:srgbClr val="000000"/>
+            </a:solidFill>
+            <a:prstDash val="dash"/>
           </a:ln>
         </p:spPr>
         <p:style>
@@ -4312,19 +4390,19 @@
       </p:cxnSp>
       <p:cxnSp>
         <p:nvCxnSpPr>
-          <p:cNvPr id="35" name="Connector 34"/>
+          <p:cNvPr id="37" name="Connector 36"/>
           <p:cNvCxnSpPr/>
           <p:nvPr/>
         </p:nvCxnSpPr>
         <p:spPr>
           <a:xfrm>
-            <a:off x="4853177" y="3115818"/>
-            <a:ext cx="77725" cy="77724"/>
+            <a:off x="3508248" y="2148840"/>
+            <a:ext cx="1560576" cy="0"/>
           </a:xfrm>
           <a:prstGeom prst="line">
             <a:avLst/>
           </a:prstGeom>
-          <a:ln w="19050">
+          <a:ln w="18415">
             <a:solidFill>
               <a:srgbClr val="000000"/>
             </a:solidFill>
@@ -4347,97 +4425,19 @@
       </p:cxnSp>
       <p:cxnSp>
         <p:nvCxnSpPr>
-          <p:cNvPr id="36" name="Connector 35"/>
-          <p:cNvCxnSpPr/>
-          <p:nvPr/>
-        </p:nvCxnSpPr>
-        <p:spPr>
-          <a:xfrm flipV="1">
-            <a:off x="4853177" y="3115818"/>
-            <a:ext cx="77725" cy="77724"/>
-          </a:xfrm>
-          <a:prstGeom prst="line">
-            <a:avLst/>
-          </a:prstGeom>
-          <a:ln w="19050">
-            <a:solidFill>
-              <a:srgbClr val="000000"/>
-            </a:solidFill>
-          </a:ln>
-        </p:spPr>
-        <p:style>
-          <a:lnRef idx="2">
-            <a:schemeClr val="accent1"/>
-          </a:lnRef>
-          <a:fillRef idx="0">
-            <a:schemeClr val="accent1"/>
-          </a:fillRef>
-          <a:effectRef idx="1">
-            <a:schemeClr val="accent1"/>
-          </a:effectRef>
-          <a:fontRef idx="minor">
-            <a:schemeClr val="tx1"/>
-          </a:fontRef>
-        </p:style>
-      </p:cxnSp>
-      <p:sp>
-        <p:nvSpPr>
-          <p:cNvPr id="37" name="Oval 36"/>
-          <p:cNvSpPr/>
-          <p:nvPr/>
-        </p:nvSpPr>
-        <p:spPr>
-          <a:xfrm>
-            <a:off x="5484571" y="3107131"/>
-            <a:ext cx="95097" cy="95097"/>
-          </a:xfrm>
-          <a:prstGeom prst="ellipse">
-            <a:avLst/>
-          </a:prstGeom>
-          <a:solidFill>
-            <a:srgbClr val="000000"/>
-          </a:solidFill>
-          <a:ln>
-            <a:noFill/>
-          </a:ln>
-        </p:spPr>
-        <p:style>
-          <a:lnRef idx="1">
-            <a:schemeClr val="accent1"/>
-          </a:lnRef>
-          <a:fillRef idx="3">
-            <a:schemeClr val="accent1"/>
-          </a:fillRef>
-          <a:effectRef idx="2">
-            <a:schemeClr val="accent1"/>
-          </a:effectRef>
-          <a:fontRef idx="minor">
-            <a:schemeClr val="lt1"/>
-          </a:fontRef>
-        </p:style>
-        <p:txBody>
-          <a:bodyPr rtlCol="0" anchor="ctr"/>
-          <a:lstStyle/>
-          <a:p>
-            <a:pPr algn="ctr"/>
-          </a:p>
-        </p:txBody>
-      </p:sp>
-      <p:cxnSp>
-        <p:nvCxnSpPr>
           <p:cNvPr id="38" name="Connector 37"/>
           <p:cNvCxnSpPr/>
           <p:nvPr/>
         </p:nvCxnSpPr>
         <p:spPr>
           <a:xfrm>
-            <a:off x="468630" y="3303270"/>
-            <a:ext cx="68580" cy="68580"/>
+            <a:off x="3476244" y="2116836"/>
+            <a:ext cx="64008" cy="64008"/>
           </a:xfrm>
           <a:prstGeom prst="line">
             <a:avLst/>
           </a:prstGeom>
-          <a:ln w="19050">
+          <a:ln w="18415">
             <a:solidFill>
               <a:srgbClr val="000000"/>
             </a:solidFill>
@@ -4466,13 +4466,13 @@
         </p:nvCxnSpPr>
         <p:spPr>
           <a:xfrm flipV="1">
-            <a:off x="468630" y="3303270"/>
-            <a:ext cx="68580" cy="68580"/>
+            <a:off x="3476244" y="2116836"/>
+            <a:ext cx="64008" cy="64008"/>
           </a:xfrm>
           <a:prstGeom prst="line">
             <a:avLst/>
           </a:prstGeom>
-          <a:ln w="19050">
+          <a:ln w="18415">
             <a:solidFill>
               <a:srgbClr val="000000"/>
             </a:solidFill>
@@ -4495,48 +4495,13 @@
       </p:cxnSp>
       <p:sp>
         <p:nvSpPr>
-          <p:cNvPr id="40" name="TextBox 39"/>
-          <p:cNvSpPr txBox="1"/>
-          <p:nvPr/>
-        </p:nvSpPr>
-        <p:spPr>
-          <a:xfrm>
-            <a:off x="649224" y="3246120"/>
-            <a:ext cx="4572000" cy="201168"/>
-          </a:xfrm>
-          <a:prstGeom prst="rect">
-            <a:avLst/>
-          </a:prstGeom>
-          <a:noFill/>
-        </p:spPr>
-        <p:txBody>
-          <a:bodyPr wrap="square">
-            <a:spAutoFit/>
-          </a:bodyPr>
-          <a:lstStyle/>
-          <a:p>
-            <a:pPr algn="l"/>
-            <a:r>
-              <a:rPr sz="800" b="0">
-                <a:solidFill>
-                  <a:srgbClr val="333333"/>
-                </a:solidFill>
-                <a:latin typeface="Arial"/>
-              </a:rPr>
-              <a:t>Ecto (SB + LDN)  ·  Meso  ·  Endo</a:t>
-            </a:r>
-          </a:p>
-        </p:txBody>
-      </p:sp>
-      <p:sp>
-        <p:nvSpPr>
-          <p:cNvPr id="41" name="Oval 40"/>
+          <p:cNvPr id="40" name="Oval 39"/>
           <p:cNvSpPr/>
           <p:nvPr/>
         </p:nvSpPr>
         <p:spPr>
           <a:xfrm>
-            <a:off x="464515" y="3555187"/>
+            <a:off x="5030419" y="2110435"/>
             <a:ext cx="76809" cy="76809"/>
           </a:xfrm>
           <a:prstGeom prst="ellipse">
@@ -4571,16 +4536,427 @@
           </a:p>
         </p:txBody>
       </p:sp>
-      <p:sp>
-        <p:nvSpPr>
-          <p:cNvPr id="42" name="TextBox 41"/>
+      <p:cxnSp>
+        <p:nvCxnSpPr>
+          <p:cNvPr id="41" name="Connector 40"/>
+          <p:cNvCxnSpPr/>
+          <p:nvPr/>
+        </p:nvCxnSpPr>
+        <p:spPr>
+          <a:xfrm>
+            <a:off x="4288536" y="918057"/>
+            <a:ext cx="0" cy="1596543"/>
+          </a:xfrm>
+          <a:prstGeom prst="line">
+            <a:avLst/>
+          </a:prstGeom>
+          <a:ln w="13970">
+            <a:solidFill>
+              <a:srgbClr val="000000"/>
+            </a:solidFill>
+            <a:prstDash val="dash"/>
+          </a:ln>
+        </p:spPr>
+        <p:style>
+          <a:lnRef idx="2">
+            <a:schemeClr val="accent1"/>
+          </a:lnRef>
+          <a:fillRef idx="0">
+            <a:schemeClr val="accent1"/>
+          </a:fillRef>
+          <a:effectRef idx="1">
+            <a:schemeClr val="accent1"/>
+          </a:effectRef>
+          <a:fontRef idx="minor">
+            <a:schemeClr val="tx1"/>
+          </a:fontRef>
+        </p:style>
+      </p:cxnSp>
+      <p:cxnSp>
+        <p:nvCxnSpPr>
+          <p:cNvPr id="42" name="Connector 41"/>
+          <p:cNvCxnSpPr/>
+          <p:nvPr/>
+        </p:nvCxnSpPr>
+        <p:spPr>
+          <a:xfrm>
+            <a:off x="4288536" y="2514600"/>
+            <a:ext cx="1560576" cy="0"/>
+          </a:xfrm>
+          <a:prstGeom prst="line">
+            <a:avLst/>
+          </a:prstGeom>
+          <a:ln w="18415">
+            <a:solidFill>
+              <a:srgbClr val="000000"/>
+            </a:solidFill>
+          </a:ln>
+        </p:spPr>
+        <p:style>
+          <a:lnRef idx="2">
+            <a:schemeClr val="accent1"/>
+          </a:lnRef>
+          <a:fillRef idx="0">
+            <a:schemeClr val="accent1"/>
+          </a:fillRef>
+          <a:effectRef idx="1">
+            <a:schemeClr val="accent1"/>
+          </a:effectRef>
+          <a:fontRef idx="minor">
+            <a:schemeClr val="tx1"/>
+          </a:fontRef>
+        </p:style>
+      </p:cxnSp>
+      <p:cxnSp>
+        <p:nvCxnSpPr>
+          <p:cNvPr id="43" name="Connector 42"/>
+          <p:cNvCxnSpPr/>
+          <p:nvPr/>
+        </p:nvCxnSpPr>
+        <p:spPr>
+          <a:xfrm>
+            <a:off x="4256531" y="2482596"/>
+            <a:ext cx="64009" cy="64008"/>
+          </a:xfrm>
+          <a:prstGeom prst="line">
+            <a:avLst/>
+          </a:prstGeom>
+          <a:ln w="18415">
+            <a:solidFill>
+              <a:srgbClr val="000000"/>
+            </a:solidFill>
+          </a:ln>
+        </p:spPr>
+        <p:style>
+          <a:lnRef idx="2">
+            <a:schemeClr val="accent1"/>
+          </a:lnRef>
+          <a:fillRef idx="0">
+            <a:schemeClr val="accent1"/>
+          </a:fillRef>
+          <a:effectRef idx="1">
+            <a:schemeClr val="accent1"/>
+          </a:effectRef>
+          <a:fontRef idx="minor">
+            <a:schemeClr val="tx1"/>
+          </a:fontRef>
+        </p:style>
+      </p:cxnSp>
+      <p:cxnSp>
+        <p:nvCxnSpPr>
+          <p:cNvPr id="44" name="Connector 43"/>
+          <p:cNvCxnSpPr/>
+          <p:nvPr/>
+        </p:nvCxnSpPr>
+        <p:spPr>
+          <a:xfrm flipV="1">
+            <a:off x="4256531" y="2482596"/>
+            <a:ext cx="64009" cy="64008"/>
+          </a:xfrm>
+          <a:prstGeom prst="line">
+            <a:avLst/>
+          </a:prstGeom>
+          <a:ln w="18415">
+            <a:solidFill>
+              <a:srgbClr val="000000"/>
+            </a:solidFill>
+          </a:ln>
+        </p:spPr>
+        <p:style>
+          <a:lnRef idx="2">
+            <a:schemeClr val="accent1"/>
+          </a:lnRef>
+          <a:fillRef idx="0">
+            <a:schemeClr val="accent1"/>
+          </a:fillRef>
+          <a:effectRef idx="1">
+            <a:schemeClr val="accent1"/>
+          </a:effectRef>
+          <a:fontRef idx="minor">
+            <a:schemeClr val="tx1"/>
+          </a:fontRef>
+        </p:style>
+      </p:cxnSp>
+      <p:sp>
+        <p:nvSpPr>
+          <p:cNvPr id="45" name="Oval 44"/>
+          <p:cNvSpPr/>
+          <p:nvPr/>
+        </p:nvSpPr>
+        <p:spPr>
+          <a:xfrm>
+            <a:off x="5810707" y="2476195"/>
+            <a:ext cx="76809" cy="76809"/>
+          </a:xfrm>
+          <a:prstGeom prst="ellipse">
+            <a:avLst/>
+          </a:prstGeom>
+          <a:solidFill>
+            <a:srgbClr val="000000"/>
+          </a:solidFill>
+          <a:ln>
+            <a:noFill/>
+          </a:ln>
+        </p:spPr>
+        <p:style>
+          <a:lnRef idx="1">
+            <a:schemeClr val="accent1"/>
+          </a:lnRef>
+          <a:fillRef idx="3">
+            <a:schemeClr val="accent1"/>
+          </a:fillRef>
+          <a:effectRef idx="2">
+            <a:schemeClr val="accent1"/>
+          </a:effectRef>
+          <a:fontRef idx="minor">
+            <a:schemeClr val="lt1"/>
+          </a:fontRef>
+        </p:style>
+        <p:txBody>
+          <a:bodyPr rtlCol="0" anchor="ctr"/>
+          <a:lstStyle/>
+          <a:p>
+            <a:pPr algn="ctr"/>
+          </a:p>
+        </p:txBody>
+      </p:sp>
+      <p:cxnSp>
+        <p:nvCxnSpPr>
+          <p:cNvPr id="46" name="Connector 45"/>
+          <p:cNvCxnSpPr/>
+          <p:nvPr/>
+        </p:nvCxnSpPr>
+        <p:spPr>
+          <a:xfrm>
+            <a:off x="5068824" y="918057"/>
+            <a:ext cx="0" cy="1916583"/>
+          </a:xfrm>
+          <a:prstGeom prst="line">
+            <a:avLst/>
+          </a:prstGeom>
+          <a:ln w="13970">
+            <a:solidFill>
+              <a:srgbClr val="000000"/>
+            </a:solidFill>
+            <a:prstDash val="dash"/>
+          </a:ln>
+        </p:spPr>
+        <p:style>
+          <a:lnRef idx="2">
+            <a:schemeClr val="accent1"/>
+          </a:lnRef>
+          <a:fillRef idx="0">
+            <a:schemeClr val="accent1"/>
+          </a:fillRef>
+          <a:effectRef idx="1">
+            <a:schemeClr val="accent1"/>
+          </a:effectRef>
+          <a:fontRef idx="minor">
+            <a:schemeClr val="tx1"/>
+          </a:fontRef>
+        </p:style>
+      </p:cxnSp>
+      <p:cxnSp>
+        <p:nvCxnSpPr>
+          <p:cNvPr id="47" name="Connector 46"/>
+          <p:cNvCxnSpPr/>
+          <p:nvPr/>
+        </p:nvCxnSpPr>
+        <p:spPr>
+          <a:xfrm>
+            <a:off x="5068824" y="2834640"/>
+            <a:ext cx="1560576" cy="0"/>
+          </a:xfrm>
+          <a:prstGeom prst="line">
+            <a:avLst/>
+          </a:prstGeom>
+          <a:ln w="18415">
+            <a:solidFill>
+              <a:srgbClr val="000000"/>
+            </a:solidFill>
+          </a:ln>
+        </p:spPr>
+        <p:style>
+          <a:lnRef idx="2">
+            <a:schemeClr val="accent1"/>
+          </a:lnRef>
+          <a:fillRef idx="0">
+            <a:schemeClr val="accent1"/>
+          </a:fillRef>
+          <a:effectRef idx="1">
+            <a:schemeClr val="accent1"/>
+          </a:effectRef>
+          <a:fontRef idx="minor">
+            <a:schemeClr val="tx1"/>
+          </a:fontRef>
+        </p:style>
+      </p:cxnSp>
+      <p:cxnSp>
+        <p:nvCxnSpPr>
+          <p:cNvPr id="48" name="Connector 47"/>
+          <p:cNvCxnSpPr/>
+          <p:nvPr/>
+        </p:nvCxnSpPr>
+        <p:spPr>
+          <a:xfrm>
+            <a:off x="5036820" y="2802636"/>
+            <a:ext cx="64008" cy="64008"/>
+          </a:xfrm>
+          <a:prstGeom prst="line">
+            <a:avLst/>
+          </a:prstGeom>
+          <a:ln w="18415">
+            <a:solidFill>
+              <a:srgbClr val="000000"/>
+            </a:solidFill>
+          </a:ln>
+        </p:spPr>
+        <p:style>
+          <a:lnRef idx="2">
+            <a:schemeClr val="accent1"/>
+          </a:lnRef>
+          <a:fillRef idx="0">
+            <a:schemeClr val="accent1"/>
+          </a:fillRef>
+          <a:effectRef idx="1">
+            <a:schemeClr val="accent1"/>
+          </a:effectRef>
+          <a:fontRef idx="minor">
+            <a:schemeClr val="tx1"/>
+          </a:fontRef>
+        </p:style>
+      </p:cxnSp>
+      <p:cxnSp>
+        <p:nvCxnSpPr>
+          <p:cNvPr id="49" name="Connector 48"/>
+          <p:cNvCxnSpPr/>
+          <p:nvPr/>
+        </p:nvCxnSpPr>
+        <p:spPr>
+          <a:xfrm flipV="1">
+            <a:off x="5036820" y="2802636"/>
+            <a:ext cx="64008" cy="64008"/>
+          </a:xfrm>
+          <a:prstGeom prst="line">
+            <a:avLst/>
+          </a:prstGeom>
+          <a:ln w="18415">
+            <a:solidFill>
+              <a:srgbClr val="000000"/>
+            </a:solidFill>
+          </a:ln>
+        </p:spPr>
+        <p:style>
+          <a:lnRef idx="2">
+            <a:schemeClr val="accent1"/>
+          </a:lnRef>
+          <a:fillRef idx="0">
+            <a:schemeClr val="accent1"/>
+          </a:fillRef>
+          <a:effectRef idx="1">
+            <a:schemeClr val="accent1"/>
+          </a:effectRef>
+          <a:fontRef idx="minor">
+            <a:schemeClr val="tx1"/>
+          </a:fontRef>
+        </p:style>
+      </p:cxnSp>
+      <p:sp>
+        <p:nvSpPr>
+          <p:cNvPr id="50" name="Oval 49"/>
+          <p:cNvSpPr/>
+          <p:nvPr/>
+        </p:nvSpPr>
+        <p:spPr>
+          <a:xfrm>
+            <a:off x="6590995" y="2796235"/>
+            <a:ext cx="76809" cy="76809"/>
+          </a:xfrm>
+          <a:prstGeom prst="ellipse">
+            <a:avLst/>
+          </a:prstGeom>
+          <a:solidFill>
+            <a:srgbClr val="000000"/>
+          </a:solidFill>
+          <a:ln>
+            <a:noFill/>
+          </a:ln>
+        </p:spPr>
+        <p:style>
+          <a:lnRef idx="1">
+            <a:schemeClr val="accent1"/>
+          </a:lnRef>
+          <a:fillRef idx="3">
+            <a:schemeClr val="accent1"/>
+          </a:fillRef>
+          <a:effectRef idx="2">
+            <a:schemeClr val="accent1"/>
+          </a:effectRef>
+          <a:fontRef idx="minor">
+            <a:schemeClr val="lt1"/>
+          </a:fontRef>
+        </p:style>
+        <p:txBody>
+          <a:bodyPr rtlCol="0" anchor="ctr"/>
+          <a:lstStyle/>
+          <a:p>
+            <a:pPr algn="ctr"/>
+          </a:p>
+        </p:txBody>
+      </p:sp>
+      <p:sp>
+        <p:nvSpPr>
+          <p:cNvPr id="51" name="Oval 50"/>
+          <p:cNvSpPr/>
+          <p:nvPr/>
+        </p:nvSpPr>
+        <p:spPr>
+          <a:xfrm>
+            <a:off x="171907" y="3061411"/>
+            <a:ext cx="58521" cy="58521"/>
+          </a:xfrm>
+          <a:prstGeom prst="ellipse">
+            <a:avLst/>
+          </a:prstGeom>
+          <a:solidFill>
+            <a:srgbClr val="000000"/>
+          </a:solidFill>
+          <a:ln>
+            <a:noFill/>
+          </a:ln>
+        </p:spPr>
+        <p:style>
+          <a:lnRef idx="1">
+            <a:schemeClr val="accent1"/>
+          </a:lnRef>
+          <a:fillRef idx="3">
+            <a:schemeClr val="accent1"/>
+          </a:fillRef>
+          <a:effectRef idx="2">
+            <a:schemeClr val="accent1"/>
+          </a:effectRef>
+          <a:fontRef idx="minor">
+            <a:schemeClr val="lt1"/>
+          </a:fontRef>
+        </p:style>
+        <p:txBody>
+          <a:bodyPr rtlCol="0" anchor="ctr"/>
+          <a:lstStyle/>
+          <a:p>
+            <a:pPr algn="ctr"/>
+          </a:p>
+        </p:txBody>
+      </p:sp>
+      <p:sp>
+        <p:nvSpPr>
+          <p:cNvPr id="52" name="TextBox 51"/>
           <p:cNvSpPr txBox="1"/>
           <p:nvPr/>
         </p:nvSpPr>
         <p:spPr>
           <a:xfrm>
-            <a:off x="649224" y="3502152"/>
-            <a:ext cx="2011680" cy="201168"/>
+            <a:off x="292608" y="3017520"/>
+            <a:ext cx="1051560" cy="164592"/>
           </a:xfrm>
           <a:prstGeom prst="rect">
             <a:avLst/>
@@ -4595,13 +4971,153 @@
           <a:p>
             <a:pPr algn="l"/>
             <a:r>
-              <a:rPr sz="800" b="0">
+              <a:rPr sz="700" b="0">
                 <a:solidFill>
                   <a:srgbClr val="333333"/>
                 </a:solidFill>
                 <a:latin typeface="Arial"/>
               </a:rPr>
               <a:t>fix &amp; stain</a:t>
+            </a:r>
+          </a:p>
+        </p:txBody>
+      </p:sp>
+      <p:sp>
+        <p:nvSpPr>
+          <p:cNvPr id="53" name="TextBox 52"/>
+          <p:cNvSpPr txBox="1"/>
+          <p:nvPr/>
+        </p:nvSpPr>
+        <p:spPr>
+          <a:xfrm>
+            <a:off x="1371600" y="3017520"/>
+            <a:ext cx="1417320" cy="164592"/>
+          </a:xfrm>
+          <a:prstGeom prst="rect">
+            <a:avLst/>
+          </a:prstGeom>
+          <a:noFill/>
+        </p:spPr>
+        <p:txBody>
+          <a:bodyPr wrap="square">
+            <a:spAutoFit/>
+          </a:bodyPr>
+          <a:lstStyle/>
+          <a:p>
+            <a:pPr algn="l"/>
+            <a:r>
+              <a:rPr sz="700" b="0">
+                <a:solidFill>
+                  <a:srgbClr val="333333"/>
+                </a:solidFill>
+                <a:latin typeface="Arial"/>
+              </a:rPr>
+              <a:t>CA  CHIR + Activin A</a:t>
+            </a:r>
+          </a:p>
+        </p:txBody>
+      </p:sp>
+      <p:cxnSp>
+        <p:nvCxnSpPr>
+          <p:cNvPr id="54" name="Connector 53"/>
+          <p:cNvCxnSpPr/>
+          <p:nvPr/>
+        </p:nvCxnSpPr>
+        <p:spPr>
+          <a:xfrm>
+            <a:off x="2898648" y="3063240"/>
+            <a:ext cx="54864" cy="54863"/>
+          </a:xfrm>
+          <a:prstGeom prst="line">
+            <a:avLst/>
+          </a:prstGeom>
+          <a:ln w="18415">
+            <a:solidFill>
+              <a:srgbClr val="000000"/>
+            </a:solidFill>
+          </a:ln>
+        </p:spPr>
+        <p:style>
+          <a:lnRef idx="2">
+            <a:schemeClr val="accent1"/>
+          </a:lnRef>
+          <a:fillRef idx="0">
+            <a:schemeClr val="accent1"/>
+          </a:fillRef>
+          <a:effectRef idx="1">
+            <a:schemeClr val="accent1"/>
+          </a:effectRef>
+          <a:fontRef idx="minor">
+            <a:schemeClr val="tx1"/>
+          </a:fontRef>
+        </p:style>
+      </p:cxnSp>
+      <p:cxnSp>
+        <p:nvCxnSpPr>
+          <p:cNvPr id="55" name="Connector 54"/>
+          <p:cNvCxnSpPr/>
+          <p:nvPr/>
+        </p:nvCxnSpPr>
+        <p:spPr>
+          <a:xfrm flipV="1">
+            <a:off x="2898648" y="3063240"/>
+            <a:ext cx="54864" cy="54863"/>
+          </a:xfrm>
+          <a:prstGeom prst="line">
+            <a:avLst/>
+          </a:prstGeom>
+          <a:ln w="18415">
+            <a:solidFill>
+              <a:srgbClr val="000000"/>
+            </a:solidFill>
+          </a:ln>
+        </p:spPr>
+        <p:style>
+          <a:lnRef idx="2">
+            <a:schemeClr val="accent1"/>
+          </a:lnRef>
+          <a:fillRef idx="0">
+            <a:schemeClr val="accent1"/>
+          </a:fillRef>
+          <a:effectRef idx="1">
+            <a:schemeClr val="accent1"/>
+          </a:effectRef>
+          <a:fontRef idx="minor">
+            <a:schemeClr val="tx1"/>
+          </a:fontRef>
+        </p:style>
+      </p:cxnSp>
+      <p:sp>
+        <p:nvSpPr>
+          <p:cNvPr id="56" name="TextBox 55"/>
+          <p:cNvSpPr txBox="1"/>
+          <p:nvPr/>
+        </p:nvSpPr>
+        <p:spPr>
+          <a:xfrm>
+            <a:off x="3035808" y="2962656"/>
+            <a:ext cx="3749039" cy="365760"/>
+          </a:xfrm>
+          <a:prstGeom prst="rect">
+            <a:avLst/>
+          </a:prstGeom>
+          <a:noFill/>
+        </p:spPr>
+        <p:txBody>
+          <a:bodyPr wrap="square">
+            <a:spAutoFit/>
+          </a:bodyPr>
+          <a:lstStyle/>
+          <a:p>
+            <a:pPr algn="l"/>
+            <a:r>
+              <a:rPr sz="700" b="0">
+                <a:solidFill>
+                  <a:srgbClr val="333333"/>
+                </a:solidFill>
+                <a:latin typeface="Arial"/>
+              </a:rPr>
+              <a:t>Ecto  d0–2 SB+LDN    Meso  d1 CHIR+Activin A+FGF; d2 BMP+SB+FGF    Endo  FGF+Activin A</a:t>
             </a:r>
           </a:p>
         </p:txBody>

</xml_diff>

<commit_message>
Refine Fig 1A phases, title, and 45° day labels
CA is d0–0.5, BMP4 is d0.5–2.5, then BMP+SCF+EGF; retitle panel;
label timepoints as 'N days' at −45°.

Co-authored-by: LiAng Yao <LiAngYao-l@users.noreply.github.com>
</commit_message>
<xml_diff>
--- a/figures/fig1a/fig1a_pgc_induction.pptx
+++ b/figures/fig1a/fig1a_pgc_induction.pptx
@@ -7,7 +7,7 @@
   <p:sldIdLst>
     <p:sldId id="256" r:id="rId7"/>
   </p:sldIdLst>
-  <p:sldSz cx="6949440" cy="3383280" type="screen4x3"/>
+  <p:sldSz cx="6949440" cy="3611880" type="screen4x3"/>
   <p:notesSz cx="6858000" cy="9144000"/>
   <p:defaultTextStyle>
     <a:defPPr>
@@ -3105,9 +3105,7 @@
           <a:noFill/>
         </p:spPr>
         <p:txBody>
-          <a:bodyPr wrap="square">
-            <a:spAutoFit/>
-          </a:bodyPr>
+          <a:bodyPr wrap="none"/>
           <a:lstStyle/>
           <a:p>
             <a:pPr algn="l"/>
@@ -3140,9 +3138,7 @@
           <a:noFill/>
         </p:spPr>
         <p:txBody>
-          <a:bodyPr wrap="square">
-            <a:spAutoFit/>
-          </a:bodyPr>
+          <a:bodyPr wrap="none"/>
           <a:lstStyle/>
           <a:p>
             <a:pPr algn="l"/>
@@ -3153,7 +3149,7 @@
                 </a:solidFill>
                 <a:latin typeface="Arial"/>
               </a:rPr>
-              <a:t>Protocols for hPGCLC specification, maintenance and DE convergence.</a:t>
+              <a:t>hPGCLC induction and timed germ-layer competency assay.</a:t>
             </a:r>
           </a:p>
         </p:txBody>
@@ -3166,8 +3162,8 @@
         </p:nvCxnSpPr>
         <p:spPr>
           <a:xfrm>
-            <a:off x="777240" y="685800"/>
-            <a:ext cx="0" cy="365760"/>
+            <a:off x="777240" y="640080"/>
+            <a:ext cx="0" cy="329184"/>
           </a:xfrm>
           <a:prstGeom prst="line">
             <a:avLst/>
@@ -3201,8 +3197,8 @@
         </p:nvSpPr>
         <p:spPr>
           <a:xfrm>
-            <a:off x="320040" y="484632"/>
-            <a:ext cx="914400" cy="182880"/>
+            <a:off x="320040" y="329184"/>
+            <a:ext cx="914400" cy="164592"/>
           </a:xfrm>
           <a:prstGeom prst="rect">
             <a:avLst/>
@@ -3210,9 +3206,7 @@
           <a:noFill/>
         </p:spPr>
         <p:txBody>
-          <a:bodyPr wrap="square">
-            <a:spAutoFit/>
-          </a:bodyPr>
+          <a:bodyPr wrap="none"/>
           <a:lstStyle/>
           <a:p>
             <a:pPr algn="ctr"/>
@@ -3236,7 +3230,7 @@
         </p:nvCxnSpPr>
         <p:spPr>
           <a:xfrm>
-            <a:off x="777240" y="868680"/>
+            <a:off x="777240" y="804672"/>
             <a:ext cx="5852160" cy="0"/>
           </a:xfrm>
           <a:prstGeom prst="line">
@@ -3263,41 +3257,41 @@
           </a:fontRef>
         </p:style>
       </p:cxnSp>
-      <p:sp>
-        <p:nvSpPr>
-          <p:cNvPr id="7" name="TextBox 6"/>
-          <p:cNvSpPr txBox="1"/>
-          <p:nvPr/>
-        </p:nvSpPr>
-        <p:spPr>
-          <a:xfrm>
-            <a:off x="777240" y="576071"/>
-            <a:ext cx="1560576" cy="182880"/>
-          </a:xfrm>
-          <a:prstGeom prst="rect">
-            <a:avLst/>
-          </a:prstGeom>
-          <a:noFill/>
-        </p:spPr>
-        <p:txBody>
-          <a:bodyPr wrap="square">
-            <a:spAutoFit/>
-          </a:bodyPr>
-          <a:lstStyle/>
-          <a:p>
-            <a:pPr algn="ctr"/>
-            <a:r>
-              <a:rPr sz="900" b="1">
-                <a:solidFill>
-                  <a:srgbClr val="000000"/>
-                </a:solidFill>
-                <a:latin typeface="Arial"/>
-              </a:rPr>
-              <a:t>CA</a:t>
-            </a:r>
-          </a:p>
-        </p:txBody>
-      </p:sp>
+      <p:cxnSp>
+        <p:nvCxnSpPr>
+          <p:cNvPr id="7" name="Connector 6"/>
+          <p:cNvCxnSpPr/>
+          <p:nvPr/>
+        </p:nvCxnSpPr>
+        <p:spPr>
+          <a:xfrm>
+            <a:off x="777240" y="713232"/>
+            <a:ext cx="390144" cy="0"/>
+          </a:xfrm>
+          <a:prstGeom prst="line">
+            <a:avLst/>
+          </a:prstGeom>
+          <a:ln w="13970">
+            <a:solidFill>
+              <a:srgbClr val="000000"/>
+            </a:solidFill>
+          </a:ln>
+        </p:spPr>
+        <p:style>
+          <a:lnRef idx="2">
+            <a:schemeClr val="accent1"/>
+          </a:lnRef>
+          <a:fillRef idx="0">
+            <a:schemeClr val="accent1"/>
+          </a:fillRef>
+          <a:effectRef idx="1">
+            <a:schemeClr val="accent1"/>
+          </a:effectRef>
+          <a:fontRef idx="minor">
+            <a:schemeClr val="tx1"/>
+          </a:fontRef>
+        </p:style>
+      </p:cxnSp>
       <p:cxnSp>
         <p:nvCxnSpPr>
           <p:cNvPr id="8" name="Connector 7"/>
@@ -3306,8 +3300,8 @@
         </p:nvCxnSpPr>
         <p:spPr>
           <a:xfrm>
-            <a:off x="777240" y="777240"/>
-            <a:ext cx="1560576" cy="0"/>
+            <a:off x="777240" y="713232"/>
+            <a:ext cx="0" cy="43891"/>
           </a:xfrm>
           <a:prstGeom prst="line">
             <a:avLst/>
@@ -3341,8 +3335,76 @@
         </p:nvCxnSpPr>
         <p:spPr>
           <a:xfrm>
-            <a:off x="777240" y="777240"/>
+            <a:off x="1167384" y="713232"/>
             <a:ext cx="0" cy="43891"/>
+          </a:xfrm>
+          <a:prstGeom prst="line">
+            <a:avLst/>
+          </a:prstGeom>
+          <a:ln w="13970">
+            <a:solidFill>
+              <a:srgbClr val="000000"/>
+            </a:solidFill>
+          </a:ln>
+        </p:spPr>
+        <p:style>
+          <a:lnRef idx="2">
+            <a:schemeClr val="accent1"/>
+          </a:lnRef>
+          <a:fillRef idx="0">
+            <a:schemeClr val="accent1"/>
+          </a:fillRef>
+          <a:effectRef idx="1">
+            <a:schemeClr val="accent1"/>
+          </a:effectRef>
+          <a:fontRef idx="minor">
+            <a:schemeClr val="tx1"/>
+          </a:fontRef>
+        </p:style>
+      </p:cxnSp>
+      <p:sp>
+        <p:nvSpPr>
+          <p:cNvPr id="10" name="TextBox 9"/>
+          <p:cNvSpPr txBox="1"/>
+          <p:nvPr/>
+        </p:nvSpPr>
+        <p:spPr>
+          <a:xfrm>
+            <a:off x="731519" y="493776"/>
+            <a:ext cx="481583" cy="182880"/>
+          </a:xfrm>
+          <a:prstGeom prst="rect">
+            <a:avLst/>
+          </a:prstGeom>
+          <a:noFill/>
+        </p:spPr>
+        <p:txBody>
+          <a:bodyPr wrap="none"/>
+          <a:lstStyle/>
+          <a:p>
+            <a:pPr algn="ctr"/>
+            <a:r>
+              <a:rPr sz="800" b="1">
+                <a:solidFill>
+                  <a:srgbClr val="000000"/>
+                </a:solidFill>
+                <a:latin typeface="Arial"/>
+              </a:rPr>
+              <a:t>CA</a:t>
+            </a:r>
+          </a:p>
+        </p:txBody>
+      </p:sp>
+      <p:cxnSp>
+        <p:nvCxnSpPr>
+          <p:cNvPr id="11" name="Connector 10"/>
+          <p:cNvCxnSpPr/>
+          <p:nvPr/>
+        </p:nvCxnSpPr>
+        <p:spPr>
+          <a:xfrm>
+            <a:off x="1167384" y="713232"/>
+            <a:ext cx="1560576" cy="0"/>
           </a:xfrm>
           <a:prstGeom prst="line">
             <a:avLst/>
@@ -3370,13 +3432,13 @@
       </p:cxnSp>
       <p:cxnSp>
         <p:nvCxnSpPr>
-          <p:cNvPr id="10" name="Connector 9"/>
+          <p:cNvPr id="12" name="Connector 11"/>
           <p:cNvCxnSpPr/>
           <p:nvPr/>
         </p:nvCxnSpPr>
         <p:spPr>
           <a:xfrm>
-            <a:off x="2337816" y="777240"/>
+            <a:off x="1167384" y="713232"/>
             <a:ext cx="0" cy="43891"/>
           </a:xfrm>
           <a:prstGeom prst="line">
@@ -3386,623 +3448,6 @@
             <a:solidFill>
               <a:srgbClr val="000000"/>
             </a:solidFill>
-          </a:ln>
-        </p:spPr>
-        <p:style>
-          <a:lnRef idx="2">
-            <a:schemeClr val="accent1"/>
-          </a:lnRef>
-          <a:fillRef idx="0">
-            <a:schemeClr val="accent1"/>
-          </a:fillRef>
-          <a:effectRef idx="1">
-            <a:schemeClr val="accent1"/>
-          </a:effectRef>
-          <a:fontRef idx="minor">
-            <a:schemeClr val="tx1"/>
-          </a:fontRef>
-        </p:style>
-      </p:cxnSp>
-      <p:sp>
-        <p:nvSpPr>
-          <p:cNvPr id="11" name="TextBox 10"/>
-          <p:cNvSpPr txBox="1"/>
-          <p:nvPr/>
-        </p:nvSpPr>
-        <p:spPr>
-          <a:xfrm>
-            <a:off x="2410968" y="576071"/>
-            <a:ext cx="4218432" cy="182880"/>
-          </a:xfrm>
-          <a:prstGeom prst="rect">
-            <a:avLst/>
-          </a:prstGeom>
-          <a:noFill/>
-        </p:spPr>
-        <p:txBody>
-          <a:bodyPr wrap="square">
-            <a:spAutoFit/>
-          </a:bodyPr>
-          <a:lstStyle/>
-          <a:p>
-            <a:pPr algn="ctr"/>
-            <a:r>
-              <a:rPr sz="1000" b="1">
-                <a:solidFill>
-                  <a:srgbClr val="000000"/>
-                </a:solidFill>
-                <a:latin typeface="Arial"/>
-              </a:rPr>
-              <a:t>BMP + SCF + EGF</a:t>
-            </a:r>
-          </a:p>
-        </p:txBody>
-      </p:sp>
-      <p:sp>
-        <p:nvSpPr>
-          <p:cNvPr id="12" name="Oval 11"/>
-          <p:cNvSpPr/>
-          <p:nvPr/>
-        </p:nvSpPr>
-        <p:spPr>
-          <a:xfrm>
-            <a:off x="1909267" y="830275"/>
-            <a:ext cx="76809" cy="76809"/>
-          </a:xfrm>
-          <a:prstGeom prst="ellipse">
-            <a:avLst/>
-          </a:prstGeom>
-          <a:solidFill>
-            <a:srgbClr val="000000"/>
-          </a:solidFill>
-          <a:ln>
-            <a:noFill/>
-          </a:ln>
-        </p:spPr>
-        <p:style>
-          <a:lnRef idx="1">
-            <a:schemeClr val="accent1"/>
-          </a:lnRef>
-          <a:fillRef idx="3">
-            <a:schemeClr val="accent1"/>
-          </a:fillRef>
-          <a:effectRef idx="2">
-            <a:schemeClr val="accent1"/>
-          </a:effectRef>
-          <a:fontRef idx="minor">
-            <a:schemeClr val="lt1"/>
-          </a:fontRef>
-        </p:style>
-        <p:txBody>
-          <a:bodyPr rtlCol="0" anchor="ctr"/>
-          <a:lstStyle/>
-          <a:p>
-            <a:pPr algn="ctr"/>
-          </a:p>
-        </p:txBody>
-      </p:sp>
-      <p:sp>
-        <p:nvSpPr>
-          <p:cNvPr id="13" name="TextBox 12"/>
-          <p:cNvSpPr txBox="1"/>
-          <p:nvPr/>
-        </p:nvSpPr>
-        <p:spPr>
-          <a:xfrm>
-            <a:off x="1673352" y="941832"/>
-            <a:ext cx="548640" cy="146304"/>
-          </a:xfrm>
-          <a:prstGeom prst="rect">
-            <a:avLst/>
-          </a:prstGeom>
-          <a:noFill/>
-        </p:spPr>
-        <p:txBody>
-          <a:bodyPr wrap="square">
-            <a:spAutoFit/>
-          </a:bodyPr>
-          <a:lstStyle/>
-          <a:p>
-            <a:pPr algn="ctr"/>
-            <a:r>
-              <a:rPr sz="700" b="0">
-                <a:solidFill>
-                  <a:srgbClr val="000000"/>
-                </a:solidFill>
-                <a:latin typeface="Arial"/>
-              </a:rPr>
-              <a:t>1.5d</a:t>
-            </a:r>
-          </a:p>
-        </p:txBody>
-      </p:sp>
-      <p:sp>
-        <p:nvSpPr>
-          <p:cNvPr id="14" name="Oval 13"/>
-          <p:cNvSpPr/>
-          <p:nvPr/>
-        </p:nvSpPr>
-        <p:spPr>
-          <a:xfrm>
-            <a:off x="2689555" y="830275"/>
-            <a:ext cx="76809" cy="76809"/>
-          </a:xfrm>
-          <a:prstGeom prst="ellipse">
-            <a:avLst/>
-          </a:prstGeom>
-          <a:solidFill>
-            <a:srgbClr val="000000"/>
-          </a:solidFill>
-          <a:ln>
-            <a:noFill/>
-          </a:ln>
-        </p:spPr>
-        <p:style>
-          <a:lnRef idx="1">
-            <a:schemeClr val="accent1"/>
-          </a:lnRef>
-          <a:fillRef idx="3">
-            <a:schemeClr val="accent1"/>
-          </a:fillRef>
-          <a:effectRef idx="2">
-            <a:schemeClr val="accent1"/>
-          </a:effectRef>
-          <a:fontRef idx="minor">
-            <a:schemeClr val="lt1"/>
-          </a:fontRef>
-        </p:style>
-        <p:txBody>
-          <a:bodyPr rtlCol="0" anchor="ctr"/>
-          <a:lstStyle/>
-          <a:p>
-            <a:pPr algn="ctr"/>
-          </a:p>
-        </p:txBody>
-      </p:sp>
-      <p:sp>
-        <p:nvSpPr>
-          <p:cNvPr id="15" name="TextBox 14"/>
-          <p:cNvSpPr txBox="1"/>
-          <p:nvPr/>
-        </p:nvSpPr>
-        <p:spPr>
-          <a:xfrm>
-            <a:off x="2453640" y="941832"/>
-            <a:ext cx="548640" cy="146304"/>
-          </a:xfrm>
-          <a:prstGeom prst="rect">
-            <a:avLst/>
-          </a:prstGeom>
-          <a:noFill/>
-        </p:spPr>
-        <p:txBody>
-          <a:bodyPr wrap="square">
-            <a:spAutoFit/>
-          </a:bodyPr>
-          <a:lstStyle/>
-          <a:p>
-            <a:pPr algn="ctr"/>
-            <a:r>
-              <a:rPr sz="700" b="0">
-                <a:solidFill>
-                  <a:srgbClr val="000000"/>
-                </a:solidFill>
-                <a:latin typeface="Arial"/>
-              </a:rPr>
-              <a:t>2.5d</a:t>
-            </a:r>
-          </a:p>
-        </p:txBody>
-      </p:sp>
-      <p:sp>
-        <p:nvSpPr>
-          <p:cNvPr id="16" name="Oval 15"/>
-          <p:cNvSpPr/>
-          <p:nvPr/>
-        </p:nvSpPr>
-        <p:spPr>
-          <a:xfrm>
-            <a:off x="3469843" y="830275"/>
-            <a:ext cx="76809" cy="76809"/>
-          </a:xfrm>
-          <a:prstGeom prst="ellipse">
-            <a:avLst/>
-          </a:prstGeom>
-          <a:solidFill>
-            <a:srgbClr val="000000"/>
-          </a:solidFill>
-          <a:ln>
-            <a:noFill/>
-          </a:ln>
-        </p:spPr>
-        <p:style>
-          <a:lnRef idx="1">
-            <a:schemeClr val="accent1"/>
-          </a:lnRef>
-          <a:fillRef idx="3">
-            <a:schemeClr val="accent1"/>
-          </a:fillRef>
-          <a:effectRef idx="2">
-            <a:schemeClr val="accent1"/>
-          </a:effectRef>
-          <a:fontRef idx="minor">
-            <a:schemeClr val="lt1"/>
-          </a:fontRef>
-        </p:style>
-        <p:txBody>
-          <a:bodyPr rtlCol="0" anchor="ctr"/>
-          <a:lstStyle/>
-          <a:p>
-            <a:pPr algn="ctr"/>
-          </a:p>
-        </p:txBody>
-      </p:sp>
-      <p:sp>
-        <p:nvSpPr>
-          <p:cNvPr id="17" name="TextBox 16"/>
-          <p:cNvSpPr txBox="1"/>
-          <p:nvPr/>
-        </p:nvSpPr>
-        <p:spPr>
-          <a:xfrm>
-            <a:off x="3233928" y="941832"/>
-            <a:ext cx="548640" cy="146304"/>
-          </a:xfrm>
-          <a:prstGeom prst="rect">
-            <a:avLst/>
-          </a:prstGeom>
-          <a:noFill/>
-        </p:spPr>
-        <p:txBody>
-          <a:bodyPr wrap="square">
-            <a:spAutoFit/>
-          </a:bodyPr>
-          <a:lstStyle/>
-          <a:p>
-            <a:pPr algn="ctr"/>
-            <a:r>
-              <a:rPr sz="700" b="0">
-                <a:solidFill>
-                  <a:srgbClr val="000000"/>
-                </a:solidFill>
-                <a:latin typeface="Arial"/>
-              </a:rPr>
-              <a:t>3.5d</a:t>
-            </a:r>
-          </a:p>
-        </p:txBody>
-      </p:sp>
-      <p:sp>
-        <p:nvSpPr>
-          <p:cNvPr id="18" name="Oval 17"/>
-          <p:cNvSpPr/>
-          <p:nvPr/>
-        </p:nvSpPr>
-        <p:spPr>
-          <a:xfrm>
-            <a:off x="4250131" y="830275"/>
-            <a:ext cx="76809" cy="76809"/>
-          </a:xfrm>
-          <a:prstGeom prst="ellipse">
-            <a:avLst/>
-          </a:prstGeom>
-          <a:solidFill>
-            <a:srgbClr val="000000"/>
-          </a:solidFill>
-          <a:ln>
-            <a:noFill/>
-          </a:ln>
-        </p:spPr>
-        <p:style>
-          <a:lnRef idx="1">
-            <a:schemeClr val="accent1"/>
-          </a:lnRef>
-          <a:fillRef idx="3">
-            <a:schemeClr val="accent1"/>
-          </a:fillRef>
-          <a:effectRef idx="2">
-            <a:schemeClr val="accent1"/>
-          </a:effectRef>
-          <a:fontRef idx="minor">
-            <a:schemeClr val="lt1"/>
-          </a:fontRef>
-        </p:style>
-        <p:txBody>
-          <a:bodyPr rtlCol="0" anchor="ctr"/>
-          <a:lstStyle/>
-          <a:p>
-            <a:pPr algn="ctr"/>
-          </a:p>
-        </p:txBody>
-      </p:sp>
-      <p:sp>
-        <p:nvSpPr>
-          <p:cNvPr id="19" name="TextBox 18"/>
-          <p:cNvSpPr txBox="1"/>
-          <p:nvPr/>
-        </p:nvSpPr>
-        <p:spPr>
-          <a:xfrm>
-            <a:off x="4014215" y="941832"/>
-            <a:ext cx="548640" cy="146304"/>
-          </a:xfrm>
-          <a:prstGeom prst="rect">
-            <a:avLst/>
-          </a:prstGeom>
-          <a:noFill/>
-        </p:spPr>
-        <p:txBody>
-          <a:bodyPr wrap="square">
-            <a:spAutoFit/>
-          </a:bodyPr>
-          <a:lstStyle/>
-          <a:p>
-            <a:pPr algn="ctr"/>
-            <a:r>
-              <a:rPr sz="700" b="0">
-                <a:solidFill>
-                  <a:srgbClr val="000000"/>
-                </a:solidFill>
-                <a:latin typeface="Arial"/>
-              </a:rPr>
-              <a:t>4.5d</a:t>
-            </a:r>
-          </a:p>
-        </p:txBody>
-      </p:sp>
-      <p:sp>
-        <p:nvSpPr>
-          <p:cNvPr id="20" name="Oval 19"/>
-          <p:cNvSpPr/>
-          <p:nvPr/>
-        </p:nvSpPr>
-        <p:spPr>
-          <a:xfrm>
-            <a:off x="5030419" y="830275"/>
-            <a:ext cx="76809" cy="76809"/>
-          </a:xfrm>
-          <a:prstGeom prst="ellipse">
-            <a:avLst/>
-          </a:prstGeom>
-          <a:solidFill>
-            <a:srgbClr val="000000"/>
-          </a:solidFill>
-          <a:ln>
-            <a:noFill/>
-          </a:ln>
-        </p:spPr>
-        <p:style>
-          <a:lnRef idx="1">
-            <a:schemeClr val="accent1"/>
-          </a:lnRef>
-          <a:fillRef idx="3">
-            <a:schemeClr val="accent1"/>
-          </a:fillRef>
-          <a:effectRef idx="2">
-            <a:schemeClr val="accent1"/>
-          </a:effectRef>
-          <a:fontRef idx="minor">
-            <a:schemeClr val="lt1"/>
-          </a:fontRef>
-        </p:style>
-        <p:txBody>
-          <a:bodyPr rtlCol="0" anchor="ctr"/>
-          <a:lstStyle/>
-          <a:p>
-            <a:pPr algn="ctr"/>
-          </a:p>
-        </p:txBody>
-      </p:sp>
-      <p:sp>
-        <p:nvSpPr>
-          <p:cNvPr id="21" name="TextBox 20"/>
-          <p:cNvSpPr txBox="1"/>
-          <p:nvPr/>
-        </p:nvSpPr>
-        <p:spPr>
-          <a:xfrm>
-            <a:off x="4794504" y="941832"/>
-            <a:ext cx="548640" cy="146304"/>
-          </a:xfrm>
-          <a:prstGeom prst="rect">
-            <a:avLst/>
-          </a:prstGeom>
-          <a:noFill/>
-        </p:spPr>
-        <p:txBody>
-          <a:bodyPr wrap="square">
-            <a:spAutoFit/>
-          </a:bodyPr>
-          <a:lstStyle/>
-          <a:p>
-            <a:pPr algn="ctr"/>
-            <a:r>
-              <a:rPr sz="700" b="0">
-                <a:solidFill>
-                  <a:srgbClr val="000000"/>
-                </a:solidFill>
-                <a:latin typeface="Arial"/>
-              </a:rPr>
-              <a:t>5.5d</a:t>
-            </a:r>
-          </a:p>
-        </p:txBody>
-      </p:sp>
-      <p:sp>
-        <p:nvSpPr>
-          <p:cNvPr id="22" name="Oval 21"/>
-          <p:cNvSpPr/>
-          <p:nvPr/>
-        </p:nvSpPr>
-        <p:spPr>
-          <a:xfrm>
-            <a:off x="5810707" y="830275"/>
-            <a:ext cx="76809" cy="76809"/>
-          </a:xfrm>
-          <a:prstGeom prst="ellipse">
-            <a:avLst/>
-          </a:prstGeom>
-          <a:solidFill>
-            <a:srgbClr val="000000"/>
-          </a:solidFill>
-          <a:ln>
-            <a:noFill/>
-          </a:ln>
-        </p:spPr>
-        <p:style>
-          <a:lnRef idx="1">
-            <a:schemeClr val="accent1"/>
-          </a:lnRef>
-          <a:fillRef idx="3">
-            <a:schemeClr val="accent1"/>
-          </a:fillRef>
-          <a:effectRef idx="2">
-            <a:schemeClr val="accent1"/>
-          </a:effectRef>
-          <a:fontRef idx="minor">
-            <a:schemeClr val="lt1"/>
-          </a:fontRef>
-        </p:style>
-        <p:txBody>
-          <a:bodyPr rtlCol="0" anchor="ctr"/>
-          <a:lstStyle/>
-          <a:p>
-            <a:pPr algn="ctr"/>
-          </a:p>
-        </p:txBody>
-      </p:sp>
-      <p:sp>
-        <p:nvSpPr>
-          <p:cNvPr id="23" name="TextBox 22"/>
-          <p:cNvSpPr txBox="1"/>
-          <p:nvPr/>
-        </p:nvSpPr>
-        <p:spPr>
-          <a:xfrm>
-            <a:off x="5574792" y="941832"/>
-            <a:ext cx="548640" cy="146304"/>
-          </a:xfrm>
-          <a:prstGeom prst="rect">
-            <a:avLst/>
-          </a:prstGeom>
-          <a:noFill/>
-        </p:spPr>
-        <p:txBody>
-          <a:bodyPr wrap="square">
-            <a:spAutoFit/>
-          </a:bodyPr>
-          <a:lstStyle/>
-          <a:p>
-            <a:pPr algn="ctr"/>
-            <a:r>
-              <a:rPr sz="700" b="0">
-                <a:solidFill>
-                  <a:srgbClr val="000000"/>
-                </a:solidFill>
-                <a:latin typeface="Arial"/>
-              </a:rPr>
-              <a:t>6.5d</a:t>
-            </a:r>
-          </a:p>
-        </p:txBody>
-      </p:sp>
-      <p:sp>
-        <p:nvSpPr>
-          <p:cNvPr id="24" name="Oval 23"/>
-          <p:cNvSpPr/>
-          <p:nvPr/>
-        </p:nvSpPr>
-        <p:spPr>
-          <a:xfrm>
-            <a:off x="6590995" y="830275"/>
-            <a:ext cx="76809" cy="76809"/>
-          </a:xfrm>
-          <a:prstGeom prst="ellipse">
-            <a:avLst/>
-          </a:prstGeom>
-          <a:solidFill>
-            <a:srgbClr val="000000"/>
-          </a:solidFill>
-          <a:ln>
-            <a:noFill/>
-          </a:ln>
-        </p:spPr>
-        <p:style>
-          <a:lnRef idx="1">
-            <a:schemeClr val="accent1"/>
-          </a:lnRef>
-          <a:fillRef idx="3">
-            <a:schemeClr val="accent1"/>
-          </a:fillRef>
-          <a:effectRef idx="2">
-            <a:schemeClr val="accent1"/>
-          </a:effectRef>
-          <a:fontRef idx="minor">
-            <a:schemeClr val="lt1"/>
-          </a:fontRef>
-        </p:style>
-        <p:txBody>
-          <a:bodyPr rtlCol="0" anchor="ctr"/>
-          <a:lstStyle/>
-          <a:p>
-            <a:pPr algn="ctr"/>
-          </a:p>
-        </p:txBody>
-      </p:sp>
-      <p:sp>
-        <p:nvSpPr>
-          <p:cNvPr id="25" name="TextBox 24"/>
-          <p:cNvSpPr txBox="1"/>
-          <p:nvPr/>
-        </p:nvSpPr>
-        <p:spPr>
-          <a:xfrm>
-            <a:off x="6355080" y="941832"/>
-            <a:ext cx="548640" cy="146304"/>
-          </a:xfrm>
-          <a:prstGeom prst="rect">
-            <a:avLst/>
-          </a:prstGeom>
-          <a:noFill/>
-        </p:spPr>
-        <p:txBody>
-          <a:bodyPr wrap="square">
-            <a:spAutoFit/>
-          </a:bodyPr>
-          <a:lstStyle/>
-          <a:p>
-            <a:pPr algn="ctr"/>
-            <a:r>
-              <a:rPr sz="700" b="0">
-                <a:solidFill>
-                  <a:srgbClr val="000000"/>
-                </a:solidFill>
-                <a:latin typeface="Arial"/>
-              </a:rPr>
-              <a:t>7.5d</a:t>
-            </a:r>
-          </a:p>
-        </p:txBody>
-      </p:sp>
-      <p:cxnSp>
-        <p:nvCxnSpPr>
-          <p:cNvPr id="26" name="Connector 25"/>
-          <p:cNvCxnSpPr/>
-          <p:nvPr/>
-        </p:nvCxnSpPr>
-        <p:spPr>
-          <a:xfrm>
-            <a:off x="1947672" y="918057"/>
-            <a:ext cx="0" cy="499263"/>
-          </a:xfrm>
-          <a:prstGeom prst="line">
-            <a:avLst/>
-          </a:prstGeom>
-          <a:ln w="13970">
-            <a:solidFill>
-              <a:srgbClr val="000000"/>
-            </a:solidFill>
-            <a:prstDash val="dash"/>
           </a:ln>
         </p:spPr>
         <p:style>
@@ -4022,19 +3467,120 @@
       </p:cxnSp>
       <p:cxnSp>
         <p:nvCxnSpPr>
-          <p:cNvPr id="27" name="Connector 26"/>
+          <p:cNvPr id="13" name="Connector 12"/>
           <p:cNvCxnSpPr/>
           <p:nvPr/>
         </p:nvCxnSpPr>
         <p:spPr>
           <a:xfrm>
-            <a:off x="1947672" y="1417320"/>
-            <a:ext cx="1560576" cy="0"/>
+            <a:off x="2727960" y="713232"/>
+            <a:ext cx="0" cy="43891"/>
           </a:xfrm>
           <a:prstGeom prst="line">
             <a:avLst/>
           </a:prstGeom>
-          <a:ln w="18415">
+          <a:ln w="13970">
+            <a:solidFill>
+              <a:srgbClr val="000000"/>
+            </a:solidFill>
+          </a:ln>
+        </p:spPr>
+        <p:style>
+          <a:lnRef idx="2">
+            <a:schemeClr val="accent1"/>
+          </a:lnRef>
+          <a:fillRef idx="0">
+            <a:schemeClr val="accent1"/>
+          </a:fillRef>
+          <a:effectRef idx="1">
+            <a:schemeClr val="accent1"/>
+          </a:effectRef>
+          <a:fontRef idx="minor">
+            <a:schemeClr val="tx1"/>
+          </a:fontRef>
+        </p:style>
+      </p:cxnSp>
+      <p:sp>
+        <p:nvSpPr>
+          <p:cNvPr id="14" name="TextBox 13"/>
+          <p:cNvSpPr txBox="1"/>
+          <p:nvPr/>
+        </p:nvSpPr>
+        <p:spPr>
+          <a:xfrm>
+            <a:off x="1121664" y="493776"/>
+            <a:ext cx="1652016" cy="182880"/>
+          </a:xfrm>
+          <a:prstGeom prst="rect">
+            <a:avLst/>
+          </a:prstGeom>
+          <a:noFill/>
+        </p:spPr>
+        <p:txBody>
+          <a:bodyPr wrap="none"/>
+          <a:lstStyle/>
+          <a:p>
+            <a:pPr algn="ctr"/>
+            <a:r>
+              <a:rPr sz="900" b="1">
+                <a:solidFill>
+                  <a:srgbClr val="000000"/>
+                </a:solidFill>
+                <a:latin typeface="Arial"/>
+              </a:rPr>
+              <a:t>BMP4</a:t>
+            </a:r>
+          </a:p>
+        </p:txBody>
+      </p:sp>
+      <p:sp>
+        <p:nvSpPr>
+          <p:cNvPr id="15" name="TextBox 14"/>
+          <p:cNvSpPr txBox="1"/>
+          <p:nvPr/>
+        </p:nvSpPr>
+        <p:spPr>
+          <a:xfrm>
+            <a:off x="2773680" y="493776"/>
+            <a:ext cx="3855720" cy="182880"/>
+          </a:xfrm>
+          <a:prstGeom prst="rect">
+            <a:avLst/>
+          </a:prstGeom>
+          <a:noFill/>
+        </p:spPr>
+        <p:txBody>
+          <a:bodyPr wrap="none"/>
+          <a:lstStyle/>
+          <a:p>
+            <a:pPr algn="ctr"/>
+            <a:r>
+              <a:rPr sz="1000" b="1">
+                <a:solidFill>
+                  <a:srgbClr val="000000"/>
+                </a:solidFill>
+                <a:latin typeface="Arial"/>
+              </a:rPr>
+              <a:t>BMP + SCF + EGF</a:t>
+            </a:r>
+          </a:p>
+        </p:txBody>
+      </p:sp>
+      <p:cxnSp>
+        <p:nvCxnSpPr>
+          <p:cNvPr id="16" name="Connector 15"/>
+          <p:cNvCxnSpPr/>
+          <p:nvPr/>
+        </p:nvCxnSpPr>
+        <p:spPr>
+          <a:xfrm>
+            <a:off x="2727960" y="713232"/>
+            <a:ext cx="3901440" cy="0"/>
+          </a:xfrm>
+          <a:prstGeom prst="line">
+            <a:avLst/>
+          </a:prstGeom>
+          <a:ln w="13970">
             <a:solidFill>
               <a:srgbClr val="000000"/>
             </a:solidFill>
@@ -4057,19 +3603,19 @@
       </p:cxnSp>
       <p:cxnSp>
         <p:nvCxnSpPr>
-          <p:cNvPr id="28" name="Connector 27"/>
+          <p:cNvPr id="17" name="Connector 16"/>
           <p:cNvCxnSpPr/>
           <p:nvPr/>
         </p:nvCxnSpPr>
         <p:spPr>
           <a:xfrm>
-            <a:off x="1915668" y="1385316"/>
-            <a:ext cx="64008" cy="64008"/>
+            <a:off x="2727960" y="713232"/>
+            <a:ext cx="0" cy="43891"/>
           </a:xfrm>
           <a:prstGeom prst="line">
             <a:avLst/>
           </a:prstGeom>
-          <a:ln w="18415">
+          <a:ln w="13970">
             <a:solidFill>
               <a:srgbClr val="000000"/>
             </a:solidFill>
@@ -4092,19 +3638,19 @@
       </p:cxnSp>
       <p:cxnSp>
         <p:nvCxnSpPr>
-          <p:cNvPr id="29" name="Connector 28"/>
+          <p:cNvPr id="18" name="Connector 17"/>
           <p:cNvCxnSpPr/>
           <p:nvPr/>
         </p:nvCxnSpPr>
         <p:spPr>
-          <a:xfrm flipV="1">
-            <a:off x="1915668" y="1385316"/>
-            <a:ext cx="64008" cy="64008"/>
+          <a:xfrm>
+            <a:off x="6629400" y="713232"/>
+            <a:ext cx="0" cy="43891"/>
           </a:xfrm>
           <a:prstGeom prst="line">
             <a:avLst/>
           </a:prstGeom>
-          <a:ln w="18415">
+          <a:ln w="13970">
             <a:solidFill>
               <a:srgbClr val="000000"/>
             </a:solidFill>
@@ -4127,13 +3673,13 @@
       </p:cxnSp>
       <p:sp>
         <p:nvSpPr>
-          <p:cNvPr id="30" name="Oval 29"/>
+          <p:cNvPr id="19" name="Oval 18"/>
           <p:cNvSpPr/>
           <p:nvPr/>
         </p:nvSpPr>
         <p:spPr>
           <a:xfrm>
-            <a:off x="3469843" y="1378915"/>
+            <a:off x="1909267" y="766267"/>
             <a:ext cx="76809" cy="76809"/>
           </a:xfrm>
           <a:prstGeom prst="ellipse">
@@ -4168,16 +3714,505 @@
           </a:p>
         </p:txBody>
       </p:sp>
+      <p:sp>
+        <p:nvSpPr>
+          <p:cNvPr id="20" name="TextBox 19"/>
+          <p:cNvSpPr txBox="1"/>
+          <p:nvPr/>
+        </p:nvSpPr>
+        <p:spPr>
+          <a:xfrm rot="18900000">
+            <a:off x="1874520" y="859536"/>
+            <a:ext cx="868680" cy="201168"/>
+          </a:xfrm>
+          <a:prstGeom prst="rect">
+            <a:avLst/>
+          </a:prstGeom>
+          <a:noFill/>
+        </p:spPr>
+        <p:txBody>
+          <a:bodyPr wrap="none"/>
+          <a:lstStyle/>
+          <a:p>
+            <a:pPr algn="l"/>
+            <a:r>
+              <a:rPr sz="750" b="0">
+                <a:solidFill>
+                  <a:srgbClr val="000000"/>
+                </a:solidFill>
+                <a:latin typeface="Arial"/>
+              </a:rPr>
+              <a:t>1.5 days</a:t>
+            </a:r>
+          </a:p>
+        </p:txBody>
+      </p:sp>
+      <p:sp>
+        <p:nvSpPr>
+          <p:cNvPr id="21" name="Oval 20"/>
+          <p:cNvSpPr/>
+          <p:nvPr/>
+        </p:nvSpPr>
+        <p:spPr>
+          <a:xfrm>
+            <a:off x="2689555" y="766267"/>
+            <a:ext cx="76809" cy="76809"/>
+          </a:xfrm>
+          <a:prstGeom prst="ellipse">
+            <a:avLst/>
+          </a:prstGeom>
+          <a:solidFill>
+            <a:srgbClr val="000000"/>
+          </a:solidFill>
+          <a:ln>
+            <a:noFill/>
+          </a:ln>
+        </p:spPr>
+        <p:style>
+          <a:lnRef idx="1">
+            <a:schemeClr val="accent1"/>
+          </a:lnRef>
+          <a:fillRef idx="3">
+            <a:schemeClr val="accent1"/>
+          </a:fillRef>
+          <a:effectRef idx="2">
+            <a:schemeClr val="accent1"/>
+          </a:effectRef>
+          <a:fontRef idx="minor">
+            <a:schemeClr val="lt1"/>
+          </a:fontRef>
+        </p:style>
+        <p:txBody>
+          <a:bodyPr rtlCol="0" anchor="ctr"/>
+          <a:lstStyle/>
+          <a:p>
+            <a:pPr algn="ctr"/>
+          </a:p>
+        </p:txBody>
+      </p:sp>
+      <p:sp>
+        <p:nvSpPr>
+          <p:cNvPr id="22" name="TextBox 21"/>
+          <p:cNvSpPr txBox="1"/>
+          <p:nvPr/>
+        </p:nvSpPr>
+        <p:spPr>
+          <a:xfrm rot="18900000">
+            <a:off x="2654808" y="859536"/>
+            <a:ext cx="868680" cy="201168"/>
+          </a:xfrm>
+          <a:prstGeom prst="rect">
+            <a:avLst/>
+          </a:prstGeom>
+          <a:noFill/>
+        </p:spPr>
+        <p:txBody>
+          <a:bodyPr wrap="none"/>
+          <a:lstStyle/>
+          <a:p>
+            <a:pPr algn="l"/>
+            <a:r>
+              <a:rPr sz="750" b="0">
+                <a:solidFill>
+                  <a:srgbClr val="000000"/>
+                </a:solidFill>
+                <a:latin typeface="Arial"/>
+              </a:rPr>
+              <a:t>2.5 days</a:t>
+            </a:r>
+          </a:p>
+        </p:txBody>
+      </p:sp>
+      <p:sp>
+        <p:nvSpPr>
+          <p:cNvPr id="23" name="Oval 22"/>
+          <p:cNvSpPr/>
+          <p:nvPr/>
+        </p:nvSpPr>
+        <p:spPr>
+          <a:xfrm>
+            <a:off x="3469843" y="766267"/>
+            <a:ext cx="76809" cy="76809"/>
+          </a:xfrm>
+          <a:prstGeom prst="ellipse">
+            <a:avLst/>
+          </a:prstGeom>
+          <a:solidFill>
+            <a:srgbClr val="000000"/>
+          </a:solidFill>
+          <a:ln>
+            <a:noFill/>
+          </a:ln>
+        </p:spPr>
+        <p:style>
+          <a:lnRef idx="1">
+            <a:schemeClr val="accent1"/>
+          </a:lnRef>
+          <a:fillRef idx="3">
+            <a:schemeClr val="accent1"/>
+          </a:fillRef>
+          <a:effectRef idx="2">
+            <a:schemeClr val="accent1"/>
+          </a:effectRef>
+          <a:fontRef idx="minor">
+            <a:schemeClr val="lt1"/>
+          </a:fontRef>
+        </p:style>
+        <p:txBody>
+          <a:bodyPr rtlCol="0" anchor="ctr"/>
+          <a:lstStyle/>
+          <a:p>
+            <a:pPr algn="ctr"/>
+          </a:p>
+        </p:txBody>
+      </p:sp>
+      <p:sp>
+        <p:nvSpPr>
+          <p:cNvPr id="24" name="TextBox 23"/>
+          <p:cNvSpPr txBox="1"/>
+          <p:nvPr/>
+        </p:nvSpPr>
+        <p:spPr>
+          <a:xfrm rot="18900000">
+            <a:off x="3435096" y="859536"/>
+            <a:ext cx="868680" cy="201168"/>
+          </a:xfrm>
+          <a:prstGeom prst="rect">
+            <a:avLst/>
+          </a:prstGeom>
+          <a:noFill/>
+        </p:spPr>
+        <p:txBody>
+          <a:bodyPr wrap="none"/>
+          <a:lstStyle/>
+          <a:p>
+            <a:pPr algn="l"/>
+            <a:r>
+              <a:rPr sz="750" b="0">
+                <a:solidFill>
+                  <a:srgbClr val="000000"/>
+                </a:solidFill>
+                <a:latin typeface="Arial"/>
+              </a:rPr>
+              <a:t>3.5 days</a:t>
+            </a:r>
+          </a:p>
+        </p:txBody>
+      </p:sp>
+      <p:sp>
+        <p:nvSpPr>
+          <p:cNvPr id="25" name="Oval 24"/>
+          <p:cNvSpPr/>
+          <p:nvPr/>
+        </p:nvSpPr>
+        <p:spPr>
+          <a:xfrm>
+            <a:off x="4250131" y="766267"/>
+            <a:ext cx="76809" cy="76809"/>
+          </a:xfrm>
+          <a:prstGeom prst="ellipse">
+            <a:avLst/>
+          </a:prstGeom>
+          <a:solidFill>
+            <a:srgbClr val="000000"/>
+          </a:solidFill>
+          <a:ln>
+            <a:noFill/>
+          </a:ln>
+        </p:spPr>
+        <p:style>
+          <a:lnRef idx="1">
+            <a:schemeClr val="accent1"/>
+          </a:lnRef>
+          <a:fillRef idx="3">
+            <a:schemeClr val="accent1"/>
+          </a:fillRef>
+          <a:effectRef idx="2">
+            <a:schemeClr val="accent1"/>
+          </a:effectRef>
+          <a:fontRef idx="minor">
+            <a:schemeClr val="lt1"/>
+          </a:fontRef>
+        </p:style>
+        <p:txBody>
+          <a:bodyPr rtlCol="0" anchor="ctr"/>
+          <a:lstStyle/>
+          <a:p>
+            <a:pPr algn="ctr"/>
+          </a:p>
+        </p:txBody>
+      </p:sp>
+      <p:sp>
+        <p:nvSpPr>
+          <p:cNvPr id="26" name="TextBox 25"/>
+          <p:cNvSpPr txBox="1"/>
+          <p:nvPr/>
+        </p:nvSpPr>
+        <p:spPr>
+          <a:xfrm rot="18900000">
+            <a:off x="4215383" y="859536"/>
+            <a:ext cx="868680" cy="201168"/>
+          </a:xfrm>
+          <a:prstGeom prst="rect">
+            <a:avLst/>
+          </a:prstGeom>
+          <a:noFill/>
+        </p:spPr>
+        <p:txBody>
+          <a:bodyPr wrap="none"/>
+          <a:lstStyle/>
+          <a:p>
+            <a:pPr algn="l"/>
+            <a:r>
+              <a:rPr sz="750" b="0">
+                <a:solidFill>
+                  <a:srgbClr val="000000"/>
+                </a:solidFill>
+                <a:latin typeface="Arial"/>
+              </a:rPr>
+              <a:t>4.5 days</a:t>
+            </a:r>
+          </a:p>
+        </p:txBody>
+      </p:sp>
+      <p:sp>
+        <p:nvSpPr>
+          <p:cNvPr id="27" name="Oval 26"/>
+          <p:cNvSpPr/>
+          <p:nvPr/>
+        </p:nvSpPr>
+        <p:spPr>
+          <a:xfrm>
+            <a:off x="5030419" y="766267"/>
+            <a:ext cx="76809" cy="76809"/>
+          </a:xfrm>
+          <a:prstGeom prst="ellipse">
+            <a:avLst/>
+          </a:prstGeom>
+          <a:solidFill>
+            <a:srgbClr val="000000"/>
+          </a:solidFill>
+          <a:ln>
+            <a:noFill/>
+          </a:ln>
+        </p:spPr>
+        <p:style>
+          <a:lnRef idx="1">
+            <a:schemeClr val="accent1"/>
+          </a:lnRef>
+          <a:fillRef idx="3">
+            <a:schemeClr val="accent1"/>
+          </a:fillRef>
+          <a:effectRef idx="2">
+            <a:schemeClr val="accent1"/>
+          </a:effectRef>
+          <a:fontRef idx="minor">
+            <a:schemeClr val="lt1"/>
+          </a:fontRef>
+        </p:style>
+        <p:txBody>
+          <a:bodyPr rtlCol="0" anchor="ctr"/>
+          <a:lstStyle/>
+          <a:p>
+            <a:pPr algn="ctr"/>
+          </a:p>
+        </p:txBody>
+      </p:sp>
+      <p:sp>
+        <p:nvSpPr>
+          <p:cNvPr id="28" name="TextBox 27"/>
+          <p:cNvSpPr txBox="1"/>
+          <p:nvPr/>
+        </p:nvSpPr>
+        <p:spPr>
+          <a:xfrm rot="18900000">
+            <a:off x="4995672" y="859536"/>
+            <a:ext cx="868680" cy="201168"/>
+          </a:xfrm>
+          <a:prstGeom prst="rect">
+            <a:avLst/>
+          </a:prstGeom>
+          <a:noFill/>
+        </p:spPr>
+        <p:txBody>
+          <a:bodyPr wrap="none"/>
+          <a:lstStyle/>
+          <a:p>
+            <a:pPr algn="l"/>
+            <a:r>
+              <a:rPr sz="750" b="0">
+                <a:solidFill>
+                  <a:srgbClr val="000000"/>
+                </a:solidFill>
+                <a:latin typeface="Arial"/>
+              </a:rPr>
+              <a:t>5.5 days</a:t>
+            </a:r>
+          </a:p>
+        </p:txBody>
+      </p:sp>
+      <p:sp>
+        <p:nvSpPr>
+          <p:cNvPr id="29" name="Oval 28"/>
+          <p:cNvSpPr/>
+          <p:nvPr/>
+        </p:nvSpPr>
+        <p:spPr>
+          <a:xfrm>
+            <a:off x="5810707" y="766267"/>
+            <a:ext cx="76809" cy="76809"/>
+          </a:xfrm>
+          <a:prstGeom prst="ellipse">
+            <a:avLst/>
+          </a:prstGeom>
+          <a:solidFill>
+            <a:srgbClr val="000000"/>
+          </a:solidFill>
+          <a:ln>
+            <a:noFill/>
+          </a:ln>
+        </p:spPr>
+        <p:style>
+          <a:lnRef idx="1">
+            <a:schemeClr val="accent1"/>
+          </a:lnRef>
+          <a:fillRef idx="3">
+            <a:schemeClr val="accent1"/>
+          </a:fillRef>
+          <a:effectRef idx="2">
+            <a:schemeClr val="accent1"/>
+          </a:effectRef>
+          <a:fontRef idx="minor">
+            <a:schemeClr val="lt1"/>
+          </a:fontRef>
+        </p:style>
+        <p:txBody>
+          <a:bodyPr rtlCol="0" anchor="ctr"/>
+          <a:lstStyle/>
+          <a:p>
+            <a:pPr algn="ctr"/>
+          </a:p>
+        </p:txBody>
+      </p:sp>
+      <p:sp>
+        <p:nvSpPr>
+          <p:cNvPr id="30" name="TextBox 29"/>
+          <p:cNvSpPr txBox="1"/>
+          <p:nvPr/>
+        </p:nvSpPr>
+        <p:spPr>
+          <a:xfrm rot="18900000">
+            <a:off x="5775960" y="859536"/>
+            <a:ext cx="868680" cy="201168"/>
+          </a:xfrm>
+          <a:prstGeom prst="rect">
+            <a:avLst/>
+          </a:prstGeom>
+          <a:noFill/>
+        </p:spPr>
+        <p:txBody>
+          <a:bodyPr wrap="none"/>
+          <a:lstStyle/>
+          <a:p>
+            <a:pPr algn="l"/>
+            <a:r>
+              <a:rPr sz="750" b="0">
+                <a:solidFill>
+                  <a:srgbClr val="000000"/>
+                </a:solidFill>
+                <a:latin typeface="Arial"/>
+              </a:rPr>
+              <a:t>6.5 days</a:t>
+            </a:r>
+          </a:p>
+        </p:txBody>
+      </p:sp>
+      <p:sp>
+        <p:nvSpPr>
+          <p:cNvPr id="31" name="Oval 30"/>
+          <p:cNvSpPr/>
+          <p:nvPr/>
+        </p:nvSpPr>
+        <p:spPr>
+          <a:xfrm>
+            <a:off x="6590995" y="766267"/>
+            <a:ext cx="76809" cy="76809"/>
+          </a:xfrm>
+          <a:prstGeom prst="ellipse">
+            <a:avLst/>
+          </a:prstGeom>
+          <a:solidFill>
+            <a:srgbClr val="000000"/>
+          </a:solidFill>
+          <a:ln>
+            <a:noFill/>
+          </a:ln>
+        </p:spPr>
+        <p:style>
+          <a:lnRef idx="1">
+            <a:schemeClr val="accent1"/>
+          </a:lnRef>
+          <a:fillRef idx="3">
+            <a:schemeClr val="accent1"/>
+          </a:fillRef>
+          <a:effectRef idx="2">
+            <a:schemeClr val="accent1"/>
+          </a:effectRef>
+          <a:fontRef idx="minor">
+            <a:schemeClr val="lt1"/>
+          </a:fontRef>
+        </p:style>
+        <p:txBody>
+          <a:bodyPr rtlCol="0" anchor="ctr"/>
+          <a:lstStyle/>
+          <a:p>
+            <a:pPr algn="ctr"/>
+          </a:p>
+        </p:txBody>
+      </p:sp>
+      <p:sp>
+        <p:nvSpPr>
+          <p:cNvPr id="32" name="TextBox 31"/>
+          <p:cNvSpPr txBox="1"/>
+          <p:nvPr/>
+        </p:nvSpPr>
+        <p:spPr>
+          <a:xfrm rot="18900000">
+            <a:off x="6556248" y="859536"/>
+            <a:ext cx="868680" cy="201168"/>
+          </a:xfrm>
+          <a:prstGeom prst="rect">
+            <a:avLst/>
+          </a:prstGeom>
+          <a:noFill/>
+        </p:spPr>
+        <p:txBody>
+          <a:bodyPr wrap="none"/>
+          <a:lstStyle/>
+          <a:p>
+            <a:pPr algn="l"/>
+            <a:r>
+              <a:rPr sz="750" b="0">
+                <a:solidFill>
+                  <a:srgbClr val="000000"/>
+                </a:solidFill>
+                <a:latin typeface="Arial"/>
+              </a:rPr>
+              <a:t>7.5 days</a:t>
+            </a:r>
+          </a:p>
+        </p:txBody>
+      </p:sp>
       <p:cxnSp>
         <p:nvCxnSpPr>
-          <p:cNvPr id="31" name="Connector 30"/>
+          <p:cNvPr id="33" name="Connector 32"/>
           <p:cNvCxnSpPr/>
           <p:nvPr/>
         </p:nvCxnSpPr>
         <p:spPr>
           <a:xfrm>
-            <a:off x="2727960" y="918057"/>
-            <a:ext cx="0" cy="865023"/>
+            <a:off x="1947672" y="854049"/>
+            <a:ext cx="0" cy="837591"/>
           </a:xfrm>
           <a:prstGeom prst="line">
             <a:avLst/>
@@ -4187,76 +4222,6 @@
               <a:srgbClr val="000000"/>
             </a:solidFill>
             <a:prstDash val="dash"/>
-          </a:ln>
-        </p:spPr>
-        <p:style>
-          <a:lnRef idx="2">
-            <a:schemeClr val="accent1"/>
-          </a:lnRef>
-          <a:fillRef idx="0">
-            <a:schemeClr val="accent1"/>
-          </a:fillRef>
-          <a:effectRef idx="1">
-            <a:schemeClr val="accent1"/>
-          </a:effectRef>
-          <a:fontRef idx="minor">
-            <a:schemeClr val="tx1"/>
-          </a:fontRef>
-        </p:style>
-      </p:cxnSp>
-      <p:cxnSp>
-        <p:nvCxnSpPr>
-          <p:cNvPr id="32" name="Connector 31"/>
-          <p:cNvCxnSpPr/>
-          <p:nvPr/>
-        </p:nvCxnSpPr>
-        <p:spPr>
-          <a:xfrm>
-            <a:off x="2727960" y="1783080"/>
-            <a:ext cx="1560576" cy="0"/>
-          </a:xfrm>
-          <a:prstGeom prst="line">
-            <a:avLst/>
-          </a:prstGeom>
-          <a:ln w="18415">
-            <a:solidFill>
-              <a:srgbClr val="000000"/>
-            </a:solidFill>
-          </a:ln>
-        </p:spPr>
-        <p:style>
-          <a:lnRef idx="2">
-            <a:schemeClr val="accent1"/>
-          </a:lnRef>
-          <a:fillRef idx="0">
-            <a:schemeClr val="accent1"/>
-          </a:fillRef>
-          <a:effectRef idx="1">
-            <a:schemeClr val="accent1"/>
-          </a:effectRef>
-          <a:fontRef idx="minor">
-            <a:schemeClr val="tx1"/>
-          </a:fontRef>
-        </p:style>
-      </p:cxnSp>
-      <p:cxnSp>
-        <p:nvCxnSpPr>
-          <p:cNvPr id="33" name="Connector 32"/>
-          <p:cNvCxnSpPr/>
-          <p:nvPr/>
-        </p:nvCxnSpPr>
-        <p:spPr>
-          <a:xfrm>
-            <a:off x="2695956" y="1751076"/>
-            <a:ext cx="64008" cy="64008"/>
-          </a:xfrm>
-          <a:prstGeom prst="line">
-            <a:avLst/>
-          </a:prstGeom>
-          <a:ln w="18415">
-            <a:solidFill>
-              <a:srgbClr val="000000"/>
-            </a:solidFill>
           </a:ln>
         </p:spPr>
         <p:style>
@@ -4281,9 +4246,9 @@
           <p:nvPr/>
         </p:nvCxnSpPr>
         <p:spPr>
-          <a:xfrm flipV="1">
-            <a:off x="2695956" y="1751076"/>
-            <a:ext cx="64008" cy="64008"/>
+          <a:xfrm>
+            <a:off x="1947672" y="1691640"/>
+            <a:ext cx="1560576" cy="0"/>
           </a:xfrm>
           <a:prstGeom prst="line">
             <a:avLst/>
@@ -4292,85 +4257,6 @@
             <a:solidFill>
               <a:srgbClr val="000000"/>
             </a:solidFill>
-          </a:ln>
-        </p:spPr>
-        <p:style>
-          <a:lnRef idx="2">
-            <a:schemeClr val="accent1"/>
-          </a:lnRef>
-          <a:fillRef idx="0">
-            <a:schemeClr val="accent1"/>
-          </a:fillRef>
-          <a:effectRef idx="1">
-            <a:schemeClr val="accent1"/>
-          </a:effectRef>
-          <a:fontRef idx="minor">
-            <a:schemeClr val="tx1"/>
-          </a:fontRef>
-        </p:style>
-      </p:cxnSp>
-      <p:sp>
-        <p:nvSpPr>
-          <p:cNvPr id="35" name="Oval 34"/>
-          <p:cNvSpPr/>
-          <p:nvPr/>
-        </p:nvSpPr>
-        <p:spPr>
-          <a:xfrm>
-            <a:off x="4250131" y="1744675"/>
-            <a:ext cx="76809" cy="76809"/>
-          </a:xfrm>
-          <a:prstGeom prst="ellipse">
-            <a:avLst/>
-          </a:prstGeom>
-          <a:solidFill>
-            <a:srgbClr val="000000"/>
-          </a:solidFill>
-          <a:ln>
-            <a:noFill/>
-          </a:ln>
-        </p:spPr>
-        <p:style>
-          <a:lnRef idx="1">
-            <a:schemeClr val="accent1"/>
-          </a:lnRef>
-          <a:fillRef idx="3">
-            <a:schemeClr val="accent1"/>
-          </a:fillRef>
-          <a:effectRef idx="2">
-            <a:schemeClr val="accent1"/>
-          </a:effectRef>
-          <a:fontRef idx="minor">
-            <a:schemeClr val="lt1"/>
-          </a:fontRef>
-        </p:style>
-        <p:txBody>
-          <a:bodyPr rtlCol="0" anchor="ctr"/>
-          <a:lstStyle/>
-          <a:p>
-            <a:pPr algn="ctr"/>
-          </a:p>
-        </p:txBody>
-      </p:sp>
-      <p:cxnSp>
-        <p:nvCxnSpPr>
-          <p:cNvPr id="36" name="Connector 35"/>
-          <p:cNvCxnSpPr/>
-          <p:nvPr/>
-        </p:nvCxnSpPr>
-        <p:spPr>
-          <a:xfrm>
-            <a:off x="3508248" y="918057"/>
-            <a:ext cx="0" cy="1230783"/>
-          </a:xfrm>
-          <a:prstGeom prst="line">
-            <a:avLst/>
-          </a:prstGeom>
-          <a:ln w="13970">
-            <a:solidFill>
-              <a:srgbClr val="000000"/>
-            </a:solidFill>
-            <a:prstDash val="dash"/>
           </a:ln>
         </p:spPr>
         <p:style>
@@ -4390,14 +4276,14 @@
       </p:cxnSp>
       <p:cxnSp>
         <p:nvCxnSpPr>
-          <p:cNvPr id="37" name="Connector 36"/>
+          <p:cNvPr id="35" name="Connector 34"/>
           <p:cNvCxnSpPr/>
           <p:nvPr/>
         </p:nvCxnSpPr>
         <p:spPr>
           <a:xfrm>
-            <a:off x="3508248" y="2148840"/>
-            <a:ext cx="1560576" cy="0"/>
+            <a:off x="1915668" y="1659636"/>
+            <a:ext cx="64008" cy="64008"/>
           </a:xfrm>
           <a:prstGeom prst="line">
             <a:avLst/>
@@ -4425,13 +4311,13 @@
       </p:cxnSp>
       <p:cxnSp>
         <p:nvCxnSpPr>
-          <p:cNvPr id="38" name="Connector 37"/>
+          <p:cNvPr id="36" name="Connector 35"/>
           <p:cNvCxnSpPr/>
           <p:nvPr/>
         </p:nvCxnSpPr>
         <p:spPr>
-          <a:xfrm>
-            <a:off x="3476244" y="2116836"/>
+          <a:xfrm flipV="1">
+            <a:off x="1915668" y="1659636"/>
             <a:ext cx="64008" cy="64008"/>
           </a:xfrm>
           <a:prstGeom prst="line">
@@ -4441,6 +4327,85 @@
             <a:solidFill>
               <a:srgbClr val="000000"/>
             </a:solidFill>
+          </a:ln>
+        </p:spPr>
+        <p:style>
+          <a:lnRef idx="2">
+            <a:schemeClr val="accent1"/>
+          </a:lnRef>
+          <a:fillRef idx="0">
+            <a:schemeClr val="accent1"/>
+          </a:fillRef>
+          <a:effectRef idx="1">
+            <a:schemeClr val="accent1"/>
+          </a:effectRef>
+          <a:fontRef idx="minor">
+            <a:schemeClr val="tx1"/>
+          </a:fontRef>
+        </p:style>
+      </p:cxnSp>
+      <p:sp>
+        <p:nvSpPr>
+          <p:cNvPr id="37" name="Oval 36"/>
+          <p:cNvSpPr/>
+          <p:nvPr/>
+        </p:nvSpPr>
+        <p:spPr>
+          <a:xfrm>
+            <a:off x="3469843" y="1653235"/>
+            <a:ext cx="76809" cy="76809"/>
+          </a:xfrm>
+          <a:prstGeom prst="ellipse">
+            <a:avLst/>
+          </a:prstGeom>
+          <a:solidFill>
+            <a:srgbClr val="000000"/>
+          </a:solidFill>
+          <a:ln>
+            <a:noFill/>
+          </a:ln>
+        </p:spPr>
+        <p:style>
+          <a:lnRef idx="1">
+            <a:schemeClr val="accent1"/>
+          </a:lnRef>
+          <a:fillRef idx="3">
+            <a:schemeClr val="accent1"/>
+          </a:fillRef>
+          <a:effectRef idx="2">
+            <a:schemeClr val="accent1"/>
+          </a:effectRef>
+          <a:fontRef idx="minor">
+            <a:schemeClr val="lt1"/>
+          </a:fontRef>
+        </p:style>
+        <p:txBody>
+          <a:bodyPr rtlCol="0" anchor="ctr"/>
+          <a:lstStyle/>
+          <a:p>
+            <a:pPr algn="ctr"/>
+          </a:p>
+        </p:txBody>
+      </p:sp>
+      <p:cxnSp>
+        <p:nvCxnSpPr>
+          <p:cNvPr id="38" name="Connector 37"/>
+          <p:cNvCxnSpPr/>
+          <p:nvPr/>
+        </p:nvCxnSpPr>
+        <p:spPr>
+          <a:xfrm>
+            <a:off x="2727960" y="854049"/>
+            <a:ext cx="0" cy="1175919"/>
+          </a:xfrm>
+          <a:prstGeom prst="line">
+            <a:avLst/>
+          </a:prstGeom>
+          <a:ln w="13970">
+            <a:solidFill>
+              <a:srgbClr val="000000"/>
+            </a:solidFill>
+            <a:prstDash val="dash"/>
           </a:ln>
         </p:spPr>
         <p:style>
@@ -4465,9 +4430,9 @@
           <p:nvPr/>
         </p:nvCxnSpPr>
         <p:spPr>
-          <a:xfrm flipV="1">
-            <a:off x="3476244" y="2116836"/>
-            <a:ext cx="64008" cy="64008"/>
+          <a:xfrm>
+            <a:off x="2727960" y="2029968"/>
+            <a:ext cx="1560576" cy="0"/>
           </a:xfrm>
           <a:prstGeom prst="line">
             <a:avLst/>
@@ -4476,85 +4441,6 @@
             <a:solidFill>
               <a:srgbClr val="000000"/>
             </a:solidFill>
-          </a:ln>
-        </p:spPr>
-        <p:style>
-          <a:lnRef idx="2">
-            <a:schemeClr val="accent1"/>
-          </a:lnRef>
-          <a:fillRef idx="0">
-            <a:schemeClr val="accent1"/>
-          </a:fillRef>
-          <a:effectRef idx="1">
-            <a:schemeClr val="accent1"/>
-          </a:effectRef>
-          <a:fontRef idx="minor">
-            <a:schemeClr val="tx1"/>
-          </a:fontRef>
-        </p:style>
-      </p:cxnSp>
-      <p:sp>
-        <p:nvSpPr>
-          <p:cNvPr id="40" name="Oval 39"/>
-          <p:cNvSpPr/>
-          <p:nvPr/>
-        </p:nvSpPr>
-        <p:spPr>
-          <a:xfrm>
-            <a:off x="5030419" y="2110435"/>
-            <a:ext cx="76809" cy="76809"/>
-          </a:xfrm>
-          <a:prstGeom prst="ellipse">
-            <a:avLst/>
-          </a:prstGeom>
-          <a:solidFill>
-            <a:srgbClr val="000000"/>
-          </a:solidFill>
-          <a:ln>
-            <a:noFill/>
-          </a:ln>
-        </p:spPr>
-        <p:style>
-          <a:lnRef idx="1">
-            <a:schemeClr val="accent1"/>
-          </a:lnRef>
-          <a:fillRef idx="3">
-            <a:schemeClr val="accent1"/>
-          </a:fillRef>
-          <a:effectRef idx="2">
-            <a:schemeClr val="accent1"/>
-          </a:effectRef>
-          <a:fontRef idx="minor">
-            <a:schemeClr val="lt1"/>
-          </a:fontRef>
-        </p:style>
-        <p:txBody>
-          <a:bodyPr rtlCol="0" anchor="ctr"/>
-          <a:lstStyle/>
-          <a:p>
-            <a:pPr algn="ctr"/>
-          </a:p>
-        </p:txBody>
-      </p:sp>
-      <p:cxnSp>
-        <p:nvCxnSpPr>
-          <p:cNvPr id="41" name="Connector 40"/>
-          <p:cNvCxnSpPr/>
-          <p:nvPr/>
-        </p:nvCxnSpPr>
-        <p:spPr>
-          <a:xfrm>
-            <a:off x="4288536" y="918057"/>
-            <a:ext cx="0" cy="1596543"/>
-          </a:xfrm>
-          <a:prstGeom prst="line">
-            <a:avLst/>
-          </a:prstGeom>
-          <a:ln w="13970">
-            <a:solidFill>
-              <a:srgbClr val="000000"/>
-            </a:solidFill>
-            <a:prstDash val="dash"/>
           </a:ln>
         </p:spPr>
         <p:style>
@@ -4574,14 +4460,14 @@
       </p:cxnSp>
       <p:cxnSp>
         <p:nvCxnSpPr>
-          <p:cNvPr id="42" name="Connector 41"/>
+          <p:cNvPr id="40" name="Connector 39"/>
           <p:cNvCxnSpPr/>
           <p:nvPr/>
         </p:nvCxnSpPr>
         <p:spPr>
           <a:xfrm>
-            <a:off x="4288536" y="2514600"/>
-            <a:ext cx="1560576" cy="0"/>
+            <a:off x="2695956" y="1997964"/>
+            <a:ext cx="64008" cy="64008"/>
           </a:xfrm>
           <a:prstGeom prst="line">
             <a:avLst/>
@@ -4609,14 +4495,14 @@
       </p:cxnSp>
       <p:cxnSp>
         <p:nvCxnSpPr>
-          <p:cNvPr id="43" name="Connector 42"/>
+          <p:cNvPr id="41" name="Connector 40"/>
           <p:cNvCxnSpPr/>
           <p:nvPr/>
         </p:nvCxnSpPr>
         <p:spPr>
-          <a:xfrm>
-            <a:off x="4256531" y="2482596"/>
-            <a:ext cx="64009" cy="64008"/>
+          <a:xfrm flipV="1">
+            <a:off x="2695956" y="1997964"/>
+            <a:ext cx="64008" cy="64008"/>
           </a:xfrm>
           <a:prstGeom prst="line">
             <a:avLst/>
@@ -4625,6 +4511,85 @@
             <a:solidFill>
               <a:srgbClr val="000000"/>
             </a:solidFill>
+          </a:ln>
+        </p:spPr>
+        <p:style>
+          <a:lnRef idx="2">
+            <a:schemeClr val="accent1"/>
+          </a:lnRef>
+          <a:fillRef idx="0">
+            <a:schemeClr val="accent1"/>
+          </a:fillRef>
+          <a:effectRef idx="1">
+            <a:schemeClr val="accent1"/>
+          </a:effectRef>
+          <a:fontRef idx="minor">
+            <a:schemeClr val="tx1"/>
+          </a:fontRef>
+        </p:style>
+      </p:cxnSp>
+      <p:sp>
+        <p:nvSpPr>
+          <p:cNvPr id="42" name="Oval 41"/>
+          <p:cNvSpPr/>
+          <p:nvPr/>
+        </p:nvSpPr>
+        <p:spPr>
+          <a:xfrm>
+            <a:off x="4250131" y="1991563"/>
+            <a:ext cx="76809" cy="76809"/>
+          </a:xfrm>
+          <a:prstGeom prst="ellipse">
+            <a:avLst/>
+          </a:prstGeom>
+          <a:solidFill>
+            <a:srgbClr val="000000"/>
+          </a:solidFill>
+          <a:ln>
+            <a:noFill/>
+          </a:ln>
+        </p:spPr>
+        <p:style>
+          <a:lnRef idx="1">
+            <a:schemeClr val="accent1"/>
+          </a:lnRef>
+          <a:fillRef idx="3">
+            <a:schemeClr val="accent1"/>
+          </a:fillRef>
+          <a:effectRef idx="2">
+            <a:schemeClr val="accent1"/>
+          </a:effectRef>
+          <a:fontRef idx="minor">
+            <a:schemeClr val="lt1"/>
+          </a:fontRef>
+        </p:style>
+        <p:txBody>
+          <a:bodyPr rtlCol="0" anchor="ctr"/>
+          <a:lstStyle/>
+          <a:p>
+            <a:pPr algn="ctr"/>
+          </a:p>
+        </p:txBody>
+      </p:sp>
+      <p:cxnSp>
+        <p:nvCxnSpPr>
+          <p:cNvPr id="43" name="Connector 42"/>
+          <p:cNvCxnSpPr/>
+          <p:nvPr/>
+        </p:nvCxnSpPr>
+        <p:spPr>
+          <a:xfrm>
+            <a:off x="3508248" y="854049"/>
+            <a:ext cx="0" cy="1514247"/>
+          </a:xfrm>
+          <a:prstGeom prst="line">
+            <a:avLst/>
+          </a:prstGeom>
+          <a:ln w="13970">
+            <a:solidFill>
+              <a:srgbClr val="000000"/>
+            </a:solidFill>
+            <a:prstDash val="dash"/>
           </a:ln>
         </p:spPr>
         <p:style>
@@ -4649,9 +4614,9 @@
           <p:nvPr/>
         </p:nvCxnSpPr>
         <p:spPr>
-          <a:xfrm flipV="1">
-            <a:off x="4256531" y="2482596"/>
-            <a:ext cx="64009" cy="64008"/>
+          <a:xfrm>
+            <a:off x="3508248" y="2368296"/>
+            <a:ext cx="1560576" cy="0"/>
           </a:xfrm>
           <a:prstGeom prst="line">
             <a:avLst/>
@@ -4660,85 +4625,6 @@
             <a:solidFill>
               <a:srgbClr val="000000"/>
             </a:solidFill>
-          </a:ln>
-        </p:spPr>
-        <p:style>
-          <a:lnRef idx="2">
-            <a:schemeClr val="accent1"/>
-          </a:lnRef>
-          <a:fillRef idx="0">
-            <a:schemeClr val="accent1"/>
-          </a:fillRef>
-          <a:effectRef idx="1">
-            <a:schemeClr val="accent1"/>
-          </a:effectRef>
-          <a:fontRef idx="minor">
-            <a:schemeClr val="tx1"/>
-          </a:fontRef>
-        </p:style>
-      </p:cxnSp>
-      <p:sp>
-        <p:nvSpPr>
-          <p:cNvPr id="45" name="Oval 44"/>
-          <p:cNvSpPr/>
-          <p:nvPr/>
-        </p:nvSpPr>
-        <p:spPr>
-          <a:xfrm>
-            <a:off x="5810707" y="2476195"/>
-            <a:ext cx="76809" cy="76809"/>
-          </a:xfrm>
-          <a:prstGeom prst="ellipse">
-            <a:avLst/>
-          </a:prstGeom>
-          <a:solidFill>
-            <a:srgbClr val="000000"/>
-          </a:solidFill>
-          <a:ln>
-            <a:noFill/>
-          </a:ln>
-        </p:spPr>
-        <p:style>
-          <a:lnRef idx="1">
-            <a:schemeClr val="accent1"/>
-          </a:lnRef>
-          <a:fillRef idx="3">
-            <a:schemeClr val="accent1"/>
-          </a:fillRef>
-          <a:effectRef idx="2">
-            <a:schemeClr val="accent1"/>
-          </a:effectRef>
-          <a:fontRef idx="minor">
-            <a:schemeClr val="lt1"/>
-          </a:fontRef>
-        </p:style>
-        <p:txBody>
-          <a:bodyPr rtlCol="0" anchor="ctr"/>
-          <a:lstStyle/>
-          <a:p>
-            <a:pPr algn="ctr"/>
-          </a:p>
-        </p:txBody>
-      </p:sp>
-      <p:cxnSp>
-        <p:nvCxnSpPr>
-          <p:cNvPr id="46" name="Connector 45"/>
-          <p:cNvCxnSpPr/>
-          <p:nvPr/>
-        </p:nvCxnSpPr>
-        <p:spPr>
-          <a:xfrm>
-            <a:off x="5068824" y="918057"/>
-            <a:ext cx="0" cy="1916583"/>
-          </a:xfrm>
-          <a:prstGeom prst="line">
-            <a:avLst/>
-          </a:prstGeom>
-          <a:ln w="13970">
-            <a:solidFill>
-              <a:srgbClr val="000000"/>
-            </a:solidFill>
-            <a:prstDash val="dash"/>
           </a:ln>
         </p:spPr>
         <p:style>
@@ -4758,14 +4644,14 @@
       </p:cxnSp>
       <p:cxnSp>
         <p:nvCxnSpPr>
-          <p:cNvPr id="47" name="Connector 46"/>
+          <p:cNvPr id="45" name="Connector 44"/>
           <p:cNvCxnSpPr/>
           <p:nvPr/>
         </p:nvCxnSpPr>
         <p:spPr>
           <a:xfrm>
-            <a:off x="5068824" y="2834640"/>
-            <a:ext cx="1560576" cy="0"/>
+            <a:off x="3476244" y="2336291"/>
+            <a:ext cx="64008" cy="64009"/>
           </a:xfrm>
           <a:prstGeom prst="line">
             <a:avLst/>
@@ -4793,14 +4679,14 @@
       </p:cxnSp>
       <p:cxnSp>
         <p:nvCxnSpPr>
-          <p:cNvPr id="48" name="Connector 47"/>
+          <p:cNvPr id="46" name="Connector 45"/>
           <p:cNvCxnSpPr/>
           <p:nvPr/>
         </p:nvCxnSpPr>
         <p:spPr>
-          <a:xfrm>
-            <a:off x="5036820" y="2802636"/>
-            <a:ext cx="64008" cy="64008"/>
+          <a:xfrm flipV="1">
+            <a:off x="3476244" y="2336291"/>
+            <a:ext cx="64008" cy="64009"/>
           </a:xfrm>
           <a:prstGeom prst="line">
             <a:avLst/>
@@ -4809,6 +4695,85 @@
             <a:solidFill>
               <a:srgbClr val="000000"/>
             </a:solidFill>
+          </a:ln>
+        </p:spPr>
+        <p:style>
+          <a:lnRef idx="2">
+            <a:schemeClr val="accent1"/>
+          </a:lnRef>
+          <a:fillRef idx="0">
+            <a:schemeClr val="accent1"/>
+          </a:fillRef>
+          <a:effectRef idx="1">
+            <a:schemeClr val="accent1"/>
+          </a:effectRef>
+          <a:fontRef idx="minor">
+            <a:schemeClr val="tx1"/>
+          </a:fontRef>
+        </p:style>
+      </p:cxnSp>
+      <p:sp>
+        <p:nvSpPr>
+          <p:cNvPr id="47" name="Oval 46"/>
+          <p:cNvSpPr/>
+          <p:nvPr/>
+        </p:nvSpPr>
+        <p:spPr>
+          <a:xfrm>
+            <a:off x="5030419" y="2329891"/>
+            <a:ext cx="76809" cy="76809"/>
+          </a:xfrm>
+          <a:prstGeom prst="ellipse">
+            <a:avLst/>
+          </a:prstGeom>
+          <a:solidFill>
+            <a:srgbClr val="000000"/>
+          </a:solidFill>
+          <a:ln>
+            <a:noFill/>
+          </a:ln>
+        </p:spPr>
+        <p:style>
+          <a:lnRef idx="1">
+            <a:schemeClr val="accent1"/>
+          </a:lnRef>
+          <a:fillRef idx="3">
+            <a:schemeClr val="accent1"/>
+          </a:fillRef>
+          <a:effectRef idx="2">
+            <a:schemeClr val="accent1"/>
+          </a:effectRef>
+          <a:fontRef idx="minor">
+            <a:schemeClr val="lt1"/>
+          </a:fontRef>
+        </p:style>
+        <p:txBody>
+          <a:bodyPr rtlCol="0" anchor="ctr"/>
+          <a:lstStyle/>
+          <a:p>
+            <a:pPr algn="ctr"/>
+          </a:p>
+        </p:txBody>
+      </p:sp>
+      <p:cxnSp>
+        <p:nvCxnSpPr>
+          <p:cNvPr id="48" name="Connector 47"/>
+          <p:cNvCxnSpPr/>
+          <p:nvPr/>
+        </p:nvCxnSpPr>
+        <p:spPr>
+          <a:xfrm>
+            <a:off x="4288536" y="854049"/>
+            <a:ext cx="0" cy="1852575"/>
+          </a:xfrm>
+          <a:prstGeom prst="line">
+            <a:avLst/>
+          </a:prstGeom>
+          <a:ln w="13970">
+            <a:solidFill>
+              <a:srgbClr val="000000"/>
+            </a:solidFill>
+            <a:prstDash val="dash"/>
           </a:ln>
         </p:spPr>
         <p:style>
@@ -4833,9 +4798,9 @@
           <p:nvPr/>
         </p:nvCxnSpPr>
         <p:spPr>
-          <a:xfrm flipV="1">
-            <a:off x="5036820" y="2802636"/>
-            <a:ext cx="64008" cy="64008"/>
+          <a:xfrm>
+            <a:off x="4288536" y="2706624"/>
+            <a:ext cx="1560576" cy="0"/>
           </a:xfrm>
           <a:prstGeom prst="line">
             <a:avLst/>
@@ -4861,15 +4826,85 @@
           </a:fontRef>
         </p:style>
       </p:cxnSp>
-      <p:sp>
-        <p:nvSpPr>
-          <p:cNvPr id="50" name="Oval 49"/>
+      <p:cxnSp>
+        <p:nvCxnSpPr>
+          <p:cNvPr id="50" name="Connector 49"/>
+          <p:cNvCxnSpPr/>
+          <p:nvPr/>
+        </p:nvCxnSpPr>
+        <p:spPr>
+          <a:xfrm>
+            <a:off x="4256531" y="2674620"/>
+            <a:ext cx="64009" cy="64008"/>
+          </a:xfrm>
+          <a:prstGeom prst="line">
+            <a:avLst/>
+          </a:prstGeom>
+          <a:ln w="18415">
+            <a:solidFill>
+              <a:srgbClr val="000000"/>
+            </a:solidFill>
+          </a:ln>
+        </p:spPr>
+        <p:style>
+          <a:lnRef idx="2">
+            <a:schemeClr val="accent1"/>
+          </a:lnRef>
+          <a:fillRef idx="0">
+            <a:schemeClr val="accent1"/>
+          </a:fillRef>
+          <a:effectRef idx="1">
+            <a:schemeClr val="accent1"/>
+          </a:effectRef>
+          <a:fontRef idx="minor">
+            <a:schemeClr val="tx1"/>
+          </a:fontRef>
+        </p:style>
+      </p:cxnSp>
+      <p:cxnSp>
+        <p:nvCxnSpPr>
+          <p:cNvPr id="51" name="Connector 50"/>
+          <p:cNvCxnSpPr/>
+          <p:nvPr/>
+        </p:nvCxnSpPr>
+        <p:spPr>
+          <a:xfrm flipV="1">
+            <a:off x="4256531" y="2674620"/>
+            <a:ext cx="64009" cy="64008"/>
+          </a:xfrm>
+          <a:prstGeom prst="line">
+            <a:avLst/>
+          </a:prstGeom>
+          <a:ln w="18415">
+            <a:solidFill>
+              <a:srgbClr val="000000"/>
+            </a:solidFill>
+          </a:ln>
+        </p:spPr>
+        <p:style>
+          <a:lnRef idx="2">
+            <a:schemeClr val="accent1"/>
+          </a:lnRef>
+          <a:fillRef idx="0">
+            <a:schemeClr val="accent1"/>
+          </a:fillRef>
+          <a:effectRef idx="1">
+            <a:schemeClr val="accent1"/>
+          </a:effectRef>
+          <a:fontRef idx="minor">
+            <a:schemeClr val="tx1"/>
+          </a:fontRef>
+        </p:style>
+      </p:cxnSp>
+      <p:sp>
+        <p:nvSpPr>
+          <p:cNvPr id="52" name="Oval 51"/>
           <p:cNvSpPr/>
           <p:nvPr/>
         </p:nvSpPr>
         <p:spPr>
           <a:xfrm>
-            <a:off x="6590995" y="2796235"/>
+            <a:off x="5810707" y="2668219"/>
             <a:ext cx="76809" cy="76809"/>
           </a:xfrm>
           <a:prstGeom prst="ellipse">
@@ -4904,119 +4939,42 @@
           </a:p>
         </p:txBody>
       </p:sp>
-      <p:sp>
-        <p:nvSpPr>
-          <p:cNvPr id="51" name="Oval 50"/>
-          <p:cNvSpPr/>
-          <p:nvPr/>
-        </p:nvSpPr>
-        <p:spPr>
-          <a:xfrm>
-            <a:off x="171907" y="3061411"/>
-            <a:ext cx="58521" cy="58521"/>
-          </a:xfrm>
-          <a:prstGeom prst="ellipse">
-            <a:avLst/>
-          </a:prstGeom>
-          <a:solidFill>
-            <a:srgbClr val="000000"/>
-          </a:solidFill>
-          <a:ln>
-            <a:noFill/>
+      <p:cxnSp>
+        <p:nvCxnSpPr>
+          <p:cNvPr id="53" name="Connector 52"/>
+          <p:cNvCxnSpPr/>
+          <p:nvPr/>
+        </p:nvCxnSpPr>
+        <p:spPr>
+          <a:xfrm>
+            <a:off x="5068824" y="854049"/>
+            <a:ext cx="0" cy="2163471"/>
+          </a:xfrm>
+          <a:prstGeom prst="line">
+            <a:avLst/>
+          </a:prstGeom>
+          <a:ln w="13970">
+            <a:solidFill>
+              <a:srgbClr val="000000"/>
+            </a:solidFill>
+            <a:prstDash val="dash"/>
           </a:ln>
         </p:spPr>
         <p:style>
-          <a:lnRef idx="1">
+          <a:lnRef idx="2">
             <a:schemeClr val="accent1"/>
           </a:lnRef>
-          <a:fillRef idx="3">
+          <a:fillRef idx="0">
             <a:schemeClr val="accent1"/>
           </a:fillRef>
-          <a:effectRef idx="2">
+          <a:effectRef idx="1">
             <a:schemeClr val="accent1"/>
           </a:effectRef>
           <a:fontRef idx="minor">
-            <a:schemeClr val="lt1"/>
+            <a:schemeClr val="tx1"/>
           </a:fontRef>
         </p:style>
-        <p:txBody>
-          <a:bodyPr rtlCol="0" anchor="ctr"/>
-          <a:lstStyle/>
-          <a:p>
-            <a:pPr algn="ctr"/>
-          </a:p>
-        </p:txBody>
-      </p:sp>
-      <p:sp>
-        <p:nvSpPr>
-          <p:cNvPr id="52" name="TextBox 51"/>
-          <p:cNvSpPr txBox="1"/>
-          <p:nvPr/>
-        </p:nvSpPr>
-        <p:spPr>
-          <a:xfrm>
-            <a:off x="292608" y="3017520"/>
-            <a:ext cx="1051560" cy="164592"/>
-          </a:xfrm>
-          <a:prstGeom prst="rect">
-            <a:avLst/>
-          </a:prstGeom>
-          <a:noFill/>
-        </p:spPr>
-        <p:txBody>
-          <a:bodyPr wrap="square">
-            <a:spAutoFit/>
-          </a:bodyPr>
-          <a:lstStyle/>
-          <a:p>
-            <a:pPr algn="l"/>
-            <a:r>
-              <a:rPr sz="700" b="0">
-                <a:solidFill>
-                  <a:srgbClr val="333333"/>
-                </a:solidFill>
-                <a:latin typeface="Arial"/>
-              </a:rPr>
-              <a:t>fix &amp; stain</a:t>
-            </a:r>
-          </a:p>
-        </p:txBody>
-      </p:sp>
-      <p:sp>
-        <p:nvSpPr>
-          <p:cNvPr id="53" name="TextBox 52"/>
-          <p:cNvSpPr txBox="1"/>
-          <p:nvPr/>
-        </p:nvSpPr>
-        <p:spPr>
-          <a:xfrm>
-            <a:off x="1371600" y="3017520"/>
-            <a:ext cx="1417320" cy="164592"/>
-          </a:xfrm>
-          <a:prstGeom prst="rect">
-            <a:avLst/>
-          </a:prstGeom>
-          <a:noFill/>
-        </p:spPr>
-        <p:txBody>
-          <a:bodyPr wrap="square">
-            <a:spAutoFit/>
-          </a:bodyPr>
-          <a:lstStyle/>
-          <a:p>
-            <a:pPr algn="l"/>
-            <a:r>
-              <a:rPr sz="700" b="0">
-                <a:solidFill>
-                  <a:srgbClr val="333333"/>
-                </a:solidFill>
-                <a:latin typeface="Arial"/>
-              </a:rPr>
-              <a:t>CA  CHIR + Activin A</a:t>
-            </a:r>
-          </a:p>
-        </p:txBody>
-      </p:sp>
+      </p:cxnSp>
       <p:cxnSp>
         <p:nvCxnSpPr>
           <p:cNvPr id="54" name="Connector 53"/>
@@ -5025,8 +4983,8 @@
         </p:nvCxnSpPr>
         <p:spPr>
           <a:xfrm>
-            <a:off x="2898648" y="3063240"/>
-            <a:ext cx="54864" cy="54863"/>
+            <a:off x="5068824" y="3017520"/>
+            <a:ext cx="1560576" cy="0"/>
           </a:xfrm>
           <a:prstGeom prst="line">
             <a:avLst/>
@@ -5059,9 +5017,9 @@
           <p:nvPr/>
         </p:nvCxnSpPr>
         <p:spPr>
-          <a:xfrm flipV="1">
-            <a:off x="2898648" y="3063240"/>
-            <a:ext cx="54864" cy="54863"/>
+          <a:xfrm>
+            <a:off x="5036820" y="2985515"/>
+            <a:ext cx="64008" cy="64009"/>
           </a:xfrm>
           <a:prstGeom prst="line">
             <a:avLst/>
@@ -5087,16 +5045,137 @@
           </a:fontRef>
         </p:style>
       </p:cxnSp>
-      <p:sp>
-        <p:nvSpPr>
-          <p:cNvPr id="56" name="TextBox 55"/>
+      <p:cxnSp>
+        <p:nvCxnSpPr>
+          <p:cNvPr id="56" name="Connector 55"/>
+          <p:cNvCxnSpPr/>
+          <p:nvPr/>
+        </p:nvCxnSpPr>
+        <p:spPr>
+          <a:xfrm flipV="1">
+            <a:off x="5036820" y="2985515"/>
+            <a:ext cx="64008" cy="64009"/>
+          </a:xfrm>
+          <a:prstGeom prst="line">
+            <a:avLst/>
+          </a:prstGeom>
+          <a:ln w="18415">
+            <a:solidFill>
+              <a:srgbClr val="000000"/>
+            </a:solidFill>
+          </a:ln>
+        </p:spPr>
+        <p:style>
+          <a:lnRef idx="2">
+            <a:schemeClr val="accent1"/>
+          </a:lnRef>
+          <a:fillRef idx="0">
+            <a:schemeClr val="accent1"/>
+          </a:fillRef>
+          <a:effectRef idx="1">
+            <a:schemeClr val="accent1"/>
+          </a:effectRef>
+          <a:fontRef idx="minor">
+            <a:schemeClr val="tx1"/>
+          </a:fontRef>
+        </p:style>
+      </p:cxnSp>
+      <p:sp>
+        <p:nvSpPr>
+          <p:cNvPr id="57" name="Oval 56"/>
+          <p:cNvSpPr/>
+          <p:nvPr/>
+        </p:nvSpPr>
+        <p:spPr>
+          <a:xfrm>
+            <a:off x="6590995" y="2979115"/>
+            <a:ext cx="76809" cy="76809"/>
+          </a:xfrm>
+          <a:prstGeom prst="ellipse">
+            <a:avLst/>
+          </a:prstGeom>
+          <a:solidFill>
+            <a:srgbClr val="000000"/>
+          </a:solidFill>
+          <a:ln>
+            <a:noFill/>
+          </a:ln>
+        </p:spPr>
+        <p:style>
+          <a:lnRef idx="1">
+            <a:schemeClr val="accent1"/>
+          </a:lnRef>
+          <a:fillRef idx="3">
+            <a:schemeClr val="accent1"/>
+          </a:fillRef>
+          <a:effectRef idx="2">
+            <a:schemeClr val="accent1"/>
+          </a:effectRef>
+          <a:fontRef idx="minor">
+            <a:schemeClr val="lt1"/>
+          </a:fontRef>
+        </p:style>
+        <p:txBody>
+          <a:bodyPr rtlCol="0" anchor="ctr"/>
+          <a:lstStyle/>
+          <a:p>
+            <a:pPr algn="ctr"/>
+          </a:p>
+        </p:txBody>
+      </p:sp>
+      <p:sp>
+        <p:nvSpPr>
+          <p:cNvPr id="58" name="Oval 57"/>
+          <p:cNvSpPr/>
+          <p:nvPr/>
+        </p:nvSpPr>
+        <p:spPr>
+          <a:xfrm>
+            <a:off x="171907" y="3271723"/>
+            <a:ext cx="58521" cy="58521"/>
+          </a:xfrm>
+          <a:prstGeom prst="ellipse">
+            <a:avLst/>
+          </a:prstGeom>
+          <a:solidFill>
+            <a:srgbClr val="000000"/>
+          </a:solidFill>
+          <a:ln>
+            <a:noFill/>
+          </a:ln>
+        </p:spPr>
+        <p:style>
+          <a:lnRef idx="1">
+            <a:schemeClr val="accent1"/>
+          </a:lnRef>
+          <a:fillRef idx="3">
+            <a:schemeClr val="accent1"/>
+          </a:fillRef>
+          <a:effectRef idx="2">
+            <a:schemeClr val="accent1"/>
+          </a:effectRef>
+          <a:fontRef idx="minor">
+            <a:schemeClr val="lt1"/>
+          </a:fontRef>
+        </p:style>
+        <p:txBody>
+          <a:bodyPr rtlCol="0" anchor="ctr"/>
+          <a:lstStyle/>
+          <a:p>
+            <a:pPr algn="ctr"/>
+          </a:p>
+        </p:txBody>
+      </p:sp>
+      <p:sp>
+        <p:nvSpPr>
+          <p:cNvPr id="59" name="TextBox 58"/>
           <p:cNvSpPr txBox="1"/>
           <p:nvPr/>
         </p:nvSpPr>
         <p:spPr>
           <a:xfrm>
-            <a:off x="3035808" y="2962656"/>
-            <a:ext cx="3749039" cy="365760"/>
+            <a:off x="292608" y="3227832"/>
+            <a:ext cx="960120" cy="164592"/>
           </a:xfrm>
           <a:prstGeom prst="rect">
             <a:avLst/>
@@ -5104,9 +5183,176 @@
           <a:noFill/>
         </p:spPr>
         <p:txBody>
-          <a:bodyPr wrap="square">
-            <a:spAutoFit/>
-          </a:bodyPr>
+          <a:bodyPr wrap="none"/>
+          <a:lstStyle/>
+          <a:p>
+            <a:pPr algn="l"/>
+            <a:r>
+              <a:rPr sz="700" b="0">
+                <a:solidFill>
+                  <a:srgbClr val="333333"/>
+                </a:solidFill>
+                <a:latin typeface="Arial"/>
+              </a:rPr>
+              <a:t>fix &amp; stain</a:t>
+            </a:r>
+          </a:p>
+        </p:txBody>
+      </p:sp>
+      <p:sp>
+        <p:nvSpPr>
+          <p:cNvPr id="60" name="TextBox 59"/>
+          <p:cNvSpPr txBox="1"/>
+          <p:nvPr/>
+        </p:nvSpPr>
+        <p:spPr>
+          <a:xfrm>
+            <a:off x="1280160" y="3227832"/>
+            <a:ext cx="1234440" cy="164592"/>
+          </a:xfrm>
+          <a:prstGeom prst="rect">
+            <a:avLst/>
+          </a:prstGeom>
+          <a:noFill/>
+        </p:spPr>
+        <p:txBody>
+          <a:bodyPr wrap="none"/>
+          <a:lstStyle/>
+          <a:p>
+            <a:pPr algn="l"/>
+            <a:r>
+              <a:rPr sz="700" b="0">
+                <a:solidFill>
+                  <a:srgbClr val="333333"/>
+                </a:solidFill>
+                <a:latin typeface="Arial"/>
+              </a:rPr>
+              <a:t>CA  CHIR + Activin A</a:t>
+            </a:r>
+          </a:p>
+        </p:txBody>
+      </p:sp>
+      <p:sp>
+        <p:nvSpPr>
+          <p:cNvPr id="61" name="TextBox 60"/>
+          <p:cNvSpPr txBox="1"/>
+          <p:nvPr/>
+        </p:nvSpPr>
+        <p:spPr>
+          <a:xfrm>
+            <a:off x="2606040" y="3227832"/>
+            <a:ext cx="640080" cy="164592"/>
+          </a:xfrm>
+          <a:prstGeom prst="rect">
+            <a:avLst/>
+          </a:prstGeom>
+          <a:noFill/>
+        </p:spPr>
+        <p:txBody>
+          <a:bodyPr wrap="none"/>
+          <a:lstStyle/>
+          <a:p>
+            <a:pPr algn="l"/>
+            <a:r>
+              <a:rPr sz="700" b="1">
+                <a:solidFill>
+                  <a:srgbClr val="333333"/>
+                </a:solidFill>
+                <a:latin typeface="Arial"/>
+              </a:rPr>
+              <a:t>BMP4</a:t>
+            </a:r>
+          </a:p>
+        </p:txBody>
+      </p:sp>
+      <p:cxnSp>
+        <p:nvCxnSpPr>
+          <p:cNvPr id="62" name="Connector 61"/>
+          <p:cNvCxnSpPr/>
+          <p:nvPr/>
+        </p:nvCxnSpPr>
+        <p:spPr>
+          <a:xfrm>
+            <a:off x="3310128" y="3273552"/>
+            <a:ext cx="54863" cy="54863"/>
+          </a:xfrm>
+          <a:prstGeom prst="line">
+            <a:avLst/>
+          </a:prstGeom>
+          <a:ln w="18415">
+            <a:solidFill>
+              <a:srgbClr val="000000"/>
+            </a:solidFill>
+          </a:ln>
+        </p:spPr>
+        <p:style>
+          <a:lnRef idx="2">
+            <a:schemeClr val="accent1"/>
+          </a:lnRef>
+          <a:fillRef idx="0">
+            <a:schemeClr val="accent1"/>
+          </a:fillRef>
+          <a:effectRef idx="1">
+            <a:schemeClr val="accent1"/>
+          </a:effectRef>
+          <a:fontRef idx="minor">
+            <a:schemeClr val="tx1"/>
+          </a:fontRef>
+        </p:style>
+      </p:cxnSp>
+      <p:cxnSp>
+        <p:nvCxnSpPr>
+          <p:cNvPr id="63" name="Connector 62"/>
+          <p:cNvCxnSpPr/>
+          <p:nvPr/>
+        </p:nvCxnSpPr>
+        <p:spPr>
+          <a:xfrm flipV="1">
+            <a:off x="3310128" y="3273552"/>
+            <a:ext cx="54863" cy="54863"/>
+          </a:xfrm>
+          <a:prstGeom prst="line">
+            <a:avLst/>
+          </a:prstGeom>
+          <a:ln w="18415">
+            <a:solidFill>
+              <a:srgbClr val="000000"/>
+            </a:solidFill>
+          </a:ln>
+        </p:spPr>
+        <p:style>
+          <a:lnRef idx="2">
+            <a:schemeClr val="accent1"/>
+          </a:lnRef>
+          <a:fillRef idx="0">
+            <a:schemeClr val="accent1"/>
+          </a:fillRef>
+          <a:effectRef idx="1">
+            <a:schemeClr val="accent1"/>
+          </a:effectRef>
+          <a:fontRef idx="minor">
+            <a:schemeClr val="tx1"/>
+          </a:fontRef>
+        </p:style>
+      </p:cxnSp>
+      <p:sp>
+        <p:nvSpPr>
+          <p:cNvPr id="64" name="TextBox 63"/>
+          <p:cNvSpPr txBox="1"/>
+          <p:nvPr/>
+        </p:nvSpPr>
+        <p:spPr>
+          <a:xfrm>
+            <a:off x="3447288" y="3172968"/>
+            <a:ext cx="3383280" cy="365760"/>
+          </a:xfrm>
+          <a:prstGeom prst="rect">
+            <a:avLst/>
+          </a:prstGeom>
+          <a:noFill/>
+        </p:spPr>
+        <p:txBody>
+          <a:bodyPr wrap="none"/>
           <a:lstStyle/>
           <a:p>
             <a:pPr algn="l"/>

</xml_diff>